<commit_message>
slide adjustments + rebuild
</commit_message>
<xml_diff>
--- a/docs/lecture_slides/Week 3/Week3_Lecture7_Slides_9_11_2026.pptx
+++ b/docs/lecture_slides/Week 3/Week3_Lecture7_Slides_9_11_2026.pptx
@@ -3362,7 +3362,7 @@
         </p:spPr>
         <p:txBody>
           <a:bodyPr>
-            <a:normAutofit/>
+            <a:noAutofit/>
           </a:bodyPr>
           <a:lstStyle/>
           <a:p>
@@ -3432,7 +3432,7 @@
           <p:cNvPr id="6" name="Body card">
             <a:extLst>
               <a:ext uri="{FF2B5EF4-FFF2-40B4-BE49-F238E27FC236}">
-                <a16:creationId xmlns:a16="http://schemas.microsoft.com/office/drawing/2014/main" id="{0362DCF9-901C-289F-E389-5A84958D349B}"/>
+                <a16:creationId xmlns:a16="http://schemas.microsoft.com/office/drawing/2014/main" id="{CB594AA7-C4EA-FBDF-927B-61DE0F32DEB6}"/>
               </a:ext>
             </a:extLst>
           </p:cNvPr>
@@ -3488,7 +3488,7 @@
           <p:cNvPr id="2" name="Title 1">
             <a:extLst>
               <a:ext uri="{FF2B5EF4-FFF2-40B4-BE49-F238E27FC236}">
-                <a16:creationId xmlns:a16="http://schemas.microsoft.com/office/drawing/2014/main" id="{4D493E66-CC51-4BAD-E816-C3A7576F85C9}"/>
+                <a16:creationId xmlns:a16="http://schemas.microsoft.com/office/drawing/2014/main" id="{4E96E5F3-99DE-CC32-5FBA-776618F83042}"/>
               </a:ext>
             </a:extLst>
           </p:cNvPr>
@@ -3501,7 +3501,9 @@
         </p:nvSpPr>
         <p:spPr/>
         <p:txBody>
-          <a:bodyPr/>
+          <a:bodyPr>
+            <a:noAutofit/>
+          </a:bodyPr>
           <a:lstStyle/>
           <a:p>
             <a:r>
@@ -3520,7 +3522,7 @@
           <p:cNvPr id="3" name="Content Placeholder 2">
             <a:extLst>
               <a:ext uri="{FF2B5EF4-FFF2-40B4-BE49-F238E27FC236}">
-                <a16:creationId xmlns:a16="http://schemas.microsoft.com/office/drawing/2014/main" id="{07F31DA3-196F-3B0A-5BE7-EB20D46DE97C}"/>
+                <a16:creationId xmlns:a16="http://schemas.microsoft.com/office/drawing/2014/main" id="{D5A4E2C4-86AE-6362-A3F7-671A4D863082}"/>
               </a:ext>
             </a:extLst>
           </p:cNvPr>
@@ -3539,7 +3541,7 @@
         </p:spPr>
         <p:txBody>
           <a:bodyPr>
-            <a:normAutofit/>
+            <a:noAutofit/>
           </a:bodyPr>
           <a:lstStyle/>
           <a:p>
@@ -3596,7 +3598,7 @@
           <p:cNvPr id="4" name="Slide Number Placeholder 3">
             <a:extLst>
               <a:ext uri="{FF2B5EF4-FFF2-40B4-BE49-F238E27FC236}">
-                <a16:creationId xmlns:a16="http://schemas.microsoft.com/office/drawing/2014/main" id="{29BDD32C-BCF2-DAD4-3F90-598F448F57DA}"/>
+                <a16:creationId xmlns:a16="http://schemas.microsoft.com/office/drawing/2014/main" id="{ADEBB848-FF85-6B44-3404-EF65EB15F4C4}"/>
               </a:ext>
             </a:extLst>
           </p:cNvPr>
@@ -3613,10 +3615,10 @@
           <a:lstStyle/>
           <a:p>
             <a:fld id="{A80A81DD-F10A-4B1C-963A-0ABBB4865886}" type="slidenum">
-              <a:rPr lang="en-US" smtClean="0"/>
+              <a:rPr lang="en-US" sz="1600" smtClean="0"/>
               <a:t>10</a:t>
             </a:fld>
-            <a:endParaRPr lang="en-US"/>
+            <a:endParaRPr lang="en-US" sz="1600"/>
           </a:p>
         </p:txBody>
       </p:sp>
@@ -3625,7 +3627,7 @@
           <p:cNvPr id="5" name="Title rule">
             <a:extLst>
               <a:ext uri="{FF2B5EF4-FFF2-40B4-BE49-F238E27FC236}">
-                <a16:creationId xmlns:a16="http://schemas.microsoft.com/office/drawing/2014/main" id="{D1E5D563-924A-AD76-85A0-4A8C481EA7EB}"/>
+                <a16:creationId xmlns:a16="http://schemas.microsoft.com/office/drawing/2014/main" id="{3C265786-5CF0-8E94-C856-DF3805A754D4}"/>
               </a:ext>
             </a:extLst>
           </p:cNvPr>
@@ -3691,7 +3693,7 @@
     </p:spTree>
     <p:extLst>
       <p:ext uri="{BB962C8B-B14F-4D97-AF65-F5344CB8AC3E}">
-        <p14:creationId xmlns:p14="http://schemas.microsoft.com/office/powerpoint/2010/main" val="2529796717"/>
+        <p14:creationId xmlns:p14="http://schemas.microsoft.com/office/powerpoint/2010/main" val="3137701456"/>
       </p:ext>
     </p:extLst>
   </p:cSld>
@@ -3723,7 +3725,7 @@
           <p:cNvPr id="6" name="Body card">
             <a:extLst>
               <a:ext uri="{FF2B5EF4-FFF2-40B4-BE49-F238E27FC236}">
-                <a16:creationId xmlns:a16="http://schemas.microsoft.com/office/drawing/2014/main" id="{46DC24E3-E11D-F69A-05FD-439A678BEC29}"/>
+                <a16:creationId xmlns:a16="http://schemas.microsoft.com/office/drawing/2014/main" id="{12AFDAB5-E74F-4433-8999-09A80FF900D0}"/>
               </a:ext>
             </a:extLst>
           </p:cNvPr>
@@ -3779,7 +3781,7 @@
           <p:cNvPr id="2" name="Title 1">
             <a:extLst>
               <a:ext uri="{FF2B5EF4-FFF2-40B4-BE49-F238E27FC236}">
-                <a16:creationId xmlns:a16="http://schemas.microsoft.com/office/drawing/2014/main" id="{D0BD1007-3C16-2775-8745-BFBF014C26EF}"/>
+                <a16:creationId xmlns:a16="http://schemas.microsoft.com/office/drawing/2014/main" id="{69EC9F1F-89E8-DB21-B02C-444F4F23762B}"/>
               </a:ext>
             </a:extLst>
           </p:cNvPr>
@@ -3792,7 +3794,9 @@
         </p:nvSpPr>
         <p:spPr/>
         <p:txBody>
-          <a:bodyPr/>
+          <a:bodyPr>
+            <a:noAutofit/>
+          </a:bodyPr>
           <a:lstStyle/>
           <a:p>
             <a:r>
@@ -3811,7 +3815,7 @@
           <p:cNvPr id="3" name="Content Placeholder 2">
             <a:extLst>
               <a:ext uri="{FF2B5EF4-FFF2-40B4-BE49-F238E27FC236}">
-                <a16:creationId xmlns:a16="http://schemas.microsoft.com/office/drawing/2014/main" id="{6D17D4A9-1B98-A406-55C5-B230E7A1992B}"/>
+                <a16:creationId xmlns:a16="http://schemas.microsoft.com/office/drawing/2014/main" id="{95C5B6D1-AE54-9329-6621-24DDB3BA5E7D}"/>
               </a:ext>
             </a:extLst>
           </p:cNvPr>
@@ -3830,7 +3834,7 @@
         </p:spPr>
         <p:txBody>
           <a:bodyPr>
-            <a:normAutofit/>
+            <a:noAutofit/>
           </a:bodyPr>
           <a:lstStyle/>
           <a:p>
@@ -3924,7 +3928,7 @@
           <p:cNvPr id="4" name="Slide Number Placeholder 3">
             <a:extLst>
               <a:ext uri="{FF2B5EF4-FFF2-40B4-BE49-F238E27FC236}">
-                <a16:creationId xmlns:a16="http://schemas.microsoft.com/office/drawing/2014/main" id="{5A636455-CD70-83B0-A593-302D614BBBA8}"/>
+                <a16:creationId xmlns:a16="http://schemas.microsoft.com/office/drawing/2014/main" id="{46D4F108-FB82-2006-E5DE-451CBB1B970D}"/>
               </a:ext>
             </a:extLst>
           </p:cNvPr>
@@ -3941,10 +3945,10 @@
           <a:lstStyle/>
           <a:p>
             <a:fld id="{A80A81DD-F10A-4B1C-963A-0ABBB4865886}" type="slidenum">
-              <a:rPr lang="en-US" smtClean="0"/>
+              <a:rPr lang="en-US" sz="1600" smtClean="0"/>
               <a:t>11</a:t>
             </a:fld>
-            <a:endParaRPr lang="en-US"/>
+            <a:endParaRPr lang="en-US" sz="1600"/>
           </a:p>
         </p:txBody>
       </p:sp>
@@ -3953,7 +3957,7 @@
           <p:cNvPr id="5" name="Title rule">
             <a:extLst>
               <a:ext uri="{FF2B5EF4-FFF2-40B4-BE49-F238E27FC236}">
-                <a16:creationId xmlns:a16="http://schemas.microsoft.com/office/drawing/2014/main" id="{DA73069E-C1E9-9849-DA6E-93E1788B1E1D}"/>
+                <a16:creationId xmlns:a16="http://schemas.microsoft.com/office/drawing/2014/main" id="{FC6005A4-1783-D4A2-CDA6-47F39C76FB44}"/>
               </a:ext>
             </a:extLst>
           </p:cNvPr>
@@ -4019,7 +4023,7 @@
     </p:spTree>
     <p:extLst>
       <p:ext uri="{BB962C8B-B14F-4D97-AF65-F5344CB8AC3E}">
-        <p14:creationId xmlns:p14="http://schemas.microsoft.com/office/powerpoint/2010/main" val="3682952333"/>
+        <p14:creationId xmlns:p14="http://schemas.microsoft.com/office/powerpoint/2010/main" val="874045400"/>
       </p:ext>
     </p:extLst>
   </p:cSld>
@@ -4051,7 +4055,7 @@
           <p:cNvPr id="6" name="Body card">
             <a:extLst>
               <a:ext uri="{FF2B5EF4-FFF2-40B4-BE49-F238E27FC236}">
-                <a16:creationId xmlns:a16="http://schemas.microsoft.com/office/drawing/2014/main" id="{275BC1EA-B7C4-A6FA-8AD8-5378AE8F49E2}"/>
+                <a16:creationId xmlns:a16="http://schemas.microsoft.com/office/drawing/2014/main" id="{19052C17-1F92-6453-7F66-661D2278FFDB}"/>
               </a:ext>
             </a:extLst>
           </p:cNvPr>
@@ -4107,7 +4111,7 @@
           <p:cNvPr id="2" name="Title 1">
             <a:extLst>
               <a:ext uri="{FF2B5EF4-FFF2-40B4-BE49-F238E27FC236}">
-                <a16:creationId xmlns:a16="http://schemas.microsoft.com/office/drawing/2014/main" id="{7CE6313B-397A-96A1-9834-BE37B602D9F0}"/>
+                <a16:creationId xmlns:a16="http://schemas.microsoft.com/office/drawing/2014/main" id="{60D473CB-584F-7685-6822-4078259455A0}"/>
               </a:ext>
             </a:extLst>
           </p:cNvPr>
@@ -4120,7 +4124,9 @@
         </p:nvSpPr>
         <p:spPr/>
         <p:txBody>
-          <a:bodyPr/>
+          <a:bodyPr>
+            <a:noAutofit/>
+          </a:bodyPr>
           <a:lstStyle/>
           <a:p>
             <a:r>
@@ -4139,7 +4145,7 @@
           <p:cNvPr id="3" name="Content Placeholder 2">
             <a:extLst>
               <a:ext uri="{FF2B5EF4-FFF2-40B4-BE49-F238E27FC236}">
-                <a16:creationId xmlns:a16="http://schemas.microsoft.com/office/drawing/2014/main" id="{D2FBE4F9-5654-408F-5789-40CE756BA271}"/>
+                <a16:creationId xmlns:a16="http://schemas.microsoft.com/office/drawing/2014/main" id="{7880F969-2EA5-050B-3E35-564ABCC9B7DD}"/>
               </a:ext>
             </a:extLst>
           </p:cNvPr>
@@ -4158,7 +4164,7 @@
         </p:spPr>
         <p:txBody>
           <a:bodyPr>
-            <a:normAutofit/>
+            <a:noAutofit/>
           </a:bodyPr>
           <a:lstStyle/>
           <a:p>
@@ -4227,7 +4233,7 @@
           <p:cNvPr id="4" name="Slide Number Placeholder 3">
             <a:extLst>
               <a:ext uri="{FF2B5EF4-FFF2-40B4-BE49-F238E27FC236}">
-                <a16:creationId xmlns:a16="http://schemas.microsoft.com/office/drawing/2014/main" id="{1EB21506-8ECB-01B5-BCDE-94A343B9AD4E}"/>
+                <a16:creationId xmlns:a16="http://schemas.microsoft.com/office/drawing/2014/main" id="{6892F58E-83AC-7FC9-02EE-ECDAF4E562F3}"/>
               </a:ext>
             </a:extLst>
           </p:cNvPr>
@@ -4244,10 +4250,10 @@
           <a:lstStyle/>
           <a:p>
             <a:fld id="{A80A81DD-F10A-4B1C-963A-0ABBB4865886}" type="slidenum">
-              <a:rPr lang="en-US" smtClean="0"/>
+              <a:rPr lang="en-US" sz="1600" smtClean="0"/>
               <a:t>12</a:t>
             </a:fld>
-            <a:endParaRPr lang="en-US"/>
+            <a:endParaRPr lang="en-US" sz="1600"/>
           </a:p>
         </p:txBody>
       </p:sp>
@@ -4256,7 +4262,7 @@
           <p:cNvPr id="5" name="Title rule">
             <a:extLst>
               <a:ext uri="{FF2B5EF4-FFF2-40B4-BE49-F238E27FC236}">
-                <a16:creationId xmlns:a16="http://schemas.microsoft.com/office/drawing/2014/main" id="{5F6F8731-BACB-0461-14D2-76C7A52348AA}"/>
+                <a16:creationId xmlns:a16="http://schemas.microsoft.com/office/drawing/2014/main" id="{750FD906-8012-0407-F732-45D7AE70632E}"/>
               </a:ext>
             </a:extLst>
           </p:cNvPr>
@@ -4322,7 +4328,7 @@
     </p:spTree>
     <p:extLst>
       <p:ext uri="{BB962C8B-B14F-4D97-AF65-F5344CB8AC3E}">
-        <p14:creationId xmlns:p14="http://schemas.microsoft.com/office/powerpoint/2010/main" val="384720882"/>
+        <p14:creationId xmlns:p14="http://schemas.microsoft.com/office/powerpoint/2010/main" val="1716717514"/>
       </p:ext>
     </p:extLst>
   </p:cSld>
@@ -4362,12 +4368,12 @@
         <p:spPr>
           <a:xfrm>
             <a:off x="838200" y="365126"/>
-            <a:ext cx="10515600" cy="519130"/>
+            <a:ext cx="10515600" cy="705104"/>
           </a:xfrm>
         </p:spPr>
         <p:txBody>
           <a:bodyPr>
-            <a:normAutofit fontScale="90000"/>
+            <a:noAutofit/>
           </a:bodyPr>
           <a:lstStyle/>
           <a:p>
@@ -4414,7 +4420,7 @@
         </p:spPr>
         <p:txBody>
           <a:bodyPr lIns="228600" tIns="182880" rIns="228600" bIns="91440" anchor="t">
-            <a:normAutofit/>
+            <a:noAutofit/>
           </a:bodyPr>
           <a:lstStyle/>
           <a:p>
@@ -4446,7 +4452,7 @@
         <p:spPr>
           <a:xfrm>
             <a:off x="1066800" y="1655688"/>
-            <a:ext cx="10058400" cy="558560"/>
+            <a:ext cx="10058400" cy="650240"/>
           </a:xfrm>
           <a:prstGeom prst="rect">
             <a:avLst/>
@@ -4455,7 +4461,7 @@
         </p:spPr>
         <p:txBody>
           <a:bodyPr wrap="square" lIns="0" tIns="0" rIns="0" bIns="0">
-            <a:normAutofit/>
+            <a:noAutofit/>
           </a:bodyPr>
           <a:lstStyle/>
           <a:p>
@@ -4505,7 +4511,7 @@
         </p:spPr>
         <p:txBody>
           <a:bodyPr lIns="228600" tIns="182880" rIns="228600" bIns="91440" anchor="t">
-            <a:normAutofit/>
+            <a:noAutofit/>
           </a:bodyPr>
           <a:lstStyle/>
           <a:p>
@@ -4546,7 +4552,7 @@
         </p:spPr>
         <p:txBody>
           <a:bodyPr wrap="square" lIns="0" tIns="0" rIns="0" bIns="0">
-            <a:normAutofit/>
+            <a:noAutofit/>
           </a:bodyPr>
           <a:lstStyle/>
           <a:p>
@@ -4596,7 +4602,7 @@
         </p:spPr>
         <p:txBody>
           <a:bodyPr lIns="228600" tIns="182880" rIns="228600" bIns="91440" anchor="t">
-            <a:normAutofit/>
+            <a:noAutofit/>
           </a:bodyPr>
           <a:lstStyle/>
           <a:p>
@@ -4637,7 +4643,7 @@
         </p:spPr>
         <p:txBody>
           <a:bodyPr wrap="square" lIns="0" tIns="0" rIns="0" bIns="0">
-            <a:normAutofit/>
+            <a:noAutofit/>
           </a:bodyPr>
           <a:lstStyle/>
           <a:p>
@@ -4687,7 +4693,7 @@
         </p:spPr>
         <p:txBody>
           <a:bodyPr lIns="228600" tIns="182880" rIns="228600" bIns="91440" anchor="t">
-            <a:normAutofit/>
+            <a:noAutofit/>
           </a:bodyPr>
           <a:lstStyle/>
           <a:p>
@@ -4719,7 +4725,7 @@
         <p:spPr>
           <a:xfrm>
             <a:off x="1066800" y="5585688"/>
-            <a:ext cx="10058400" cy="558560"/>
+            <a:ext cx="10058400" cy="589280"/>
           </a:xfrm>
           <a:prstGeom prst="rect">
             <a:avLst/>
@@ -4728,7 +4734,7 @@
         </p:spPr>
         <p:txBody>
           <a:bodyPr wrap="square" lIns="0" tIns="0" rIns="0" bIns="0">
-            <a:normAutofit/>
+            <a:noAutofit/>
           </a:bodyPr>
           <a:lstStyle/>
           <a:p>
@@ -4773,10 +4779,10 @@
           <a:lstStyle/>
           <a:p>
             <a:fld id="{A80A81DD-F10A-4B1C-963A-0ABBB4865886}" type="slidenum">
-              <a:rPr lang="en-US" smtClean="0"/>
+              <a:rPr lang="en-US" sz="1600" smtClean="0"/>
               <a:t>2</a:t>
             </a:fld>
-            <a:endParaRPr lang="en-US"/>
+            <a:endParaRPr lang="en-US" sz="1600"/>
           </a:p>
         </p:txBody>
       </p:sp>
@@ -5205,7 +5211,7 @@
           <p:cNvPr id="2" name="Title 1">
             <a:extLst>
               <a:ext uri="{FF2B5EF4-FFF2-40B4-BE49-F238E27FC236}">
-                <a16:creationId xmlns:a16="http://schemas.microsoft.com/office/drawing/2014/main" id="{A1234F4C-FB53-4118-F743-331A0F2BF227}"/>
+                <a16:creationId xmlns:a16="http://schemas.microsoft.com/office/drawing/2014/main" id="{1DD6648B-0865-9132-90F9-10BB6FCE9588}"/>
               </a:ext>
             </a:extLst>
           </p:cNvPr>
@@ -5218,7 +5224,9 @@
         </p:nvSpPr>
         <p:spPr/>
         <p:txBody>
-          <a:bodyPr/>
+          <a:bodyPr>
+            <a:noAutofit/>
+          </a:bodyPr>
           <a:lstStyle/>
           <a:p>
             <a:r>
@@ -5237,7 +5245,7 @@
           <p:cNvPr id="3" name="Content Placeholder 2">
             <a:extLst>
               <a:ext uri="{FF2B5EF4-FFF2-40B4-BE49-F238E27FC236}">
-                <a16:creationId xmlns:a16="http://schemas.microsoft.com/office/drawing/2014/main" id="{3A168E70-1EE1-D19D-D8E5-097C6C609F0E}"/>
+                <a16:creationId xmlns:a16="http://schemas.microsoft.com/office/drawing/2014/main" id="{9F6ADC10-16D0-6901-D9F9-6D3C1FC9C20F}"/>
               </a:ext>
             </a:extLst>
           </p:cNvPr>
@@ -5256,7 +5264,7 @@
         </p:spPr>
         <p:txBody>
           <a:bodyPr>
-            <a:normAutofit/>
+            <a:noAutofit/>
           </a:bodyPr>
           <a:lstStyle/>
           <a:p>
@@ -5278,7 +5286,7 @@
           <p:cNvPr id="4" name="Slide Number Placeholder 3">
             <a:extLst>
               <a:ext uri="{FF2B5EF4-FFF2-40B4-BE49-F238E27FC236}">
-                <a16:creationId xmlns:a16="http://schemas.microsoft.com/office/drawing/2014/main" id="{3678B7B7-A29D-1936-239B-AA7C0D61EC8C}"/>
+                <a16:creationId xmlns:a16="http://schemas.microsoft.com/office/drawing/2014/main" id="{43893403-3859-CC92-8D35-8EBF165ED734}"/>
               </a:ext>
             </a:extLst>
           </p:cNvPr>
@@ -5295,10 +5303,10 @@
           <a:lstStyle/>
           <a:p>
             <a:fld id="{A80A81DD-F10A-4B1C-963A-0ABBB4865886}" type="slidenum">
-              <a:rPr lang="en-US" smtClean="0"/>
+              <a:rPr lang="en-US" sz="1600" smtClean="0"/>
               <a:t>3</a:t>
             </a:fld>
-            <a:endParaRPr lang="en-US"/>
+            <a:endParaRPr lang="en-US" sz="1600"/>
           </a:p>
         </p:txBody>
       </p:sp>
@@ -5307,7 +5315,7 @@
           <p:cNvPr id="6" name="Picture 5">
             <a:extLst>
               <a:ext uri="{FF2B5EF4-FFF2-40B4-BE49-F238E27FC236}">
-                <a16:creationId xmlns:a16="http://schemas.microsoft.com/office/drawing/2014/main" id="{AAF37F9E-257B-2A40-9DD4-6B3705C2F972}"/>
+                <a16:creationId xmlns:a16="http://schemas.microsoft.com/office/drawing/2014/main" id="{30217016-297D-1D7B-29E9-D10BC7C80C52}"/>
               </a:ext>
             </a:extLst>
           </p:cNvPr>
@@ -5343,7 +5351,7 @@
           <p:cNvPr id="5" name="Title rule">
             <a:extLst>
               <a:ext uri="{FF2B5EF4-FFF2-40B4-BE49-F238E27FC236}">
-                <a16:creationId xmlns:a16="http://schemas.microsoft.com/office/drawing/2014/main" id="{62513807-7016-F666-1AD1-C87ACA26BD3A}"/>
+                <a16:creationId xmlns:a16="http://schemas.microsoft.com/office/drawing/2014/main" id="{817933A3-21BC-7D51-D9B0-DD4C89F77728}"/>
               </a:ext>
             </a:extLst>
           </p:cNvPr>
@@ -5409,7 +5417,7 @@
     </p:spTree>
     <p:extLst>
       <p:ext uri="{BB962C8B-B14F-4D97-AF65-F5344CB8AC3E}">
-        <p14:creationId xmlns:p14="http://schemas.microsoft.com/office/powerpoint/2010/main" val="1392173608"/>
+        <p14:creationId xmlns:p14="http://schemas.microsoft.com/office/powerpoint/2010/main" val="1297402917"/>
       </p:ext>
     </p:extLst>
   </p:cSld>
@@ -5441,7 +5449,7 @@
           <p:cNvPr id="2" name="Title 1">
             <a:extLst>
               <a:ext uri="{FF2B5EF4-FFF2-40B4-BE49-F238E27FC236}">
-                <a16:creationId xmlns:a16="http://schemas.microsoft.com/office/drawing/2014/main" id="{2AB5768F-DA0B-F50C-0F6F-2B3E507F859A}"/>
+                <a16:creationId xmlns:a16="http://schemas.microsoft.com/office/drawing/2014/main" id="{9EB80FFE-FD3E-F5BF-5ABE-77ED966A51D4}"/>
               </a:ext>
             </a:extLst>
           </p:cNvPr>
@@ -5454,7 +5462,9 @@
         </p:nvSpPr>
         <p:spPr/>
         <p:txBody>
-          <a:bodyPr/>
+          <a:bodyPr>
+            <a:noAutofit/>
+          </a:bodyPr>
           <a:lstStyle/>
           <a:p>
             <a:r>
@@ -5473,7 +5483,7 @@
           <p:cNvPr id="3" name="Content Placeholder 2">
             <a:extLst>
               <a:ext uri="{FF2B5EF4-FFF2-40B4-BE49-F238E27FC236}">
-                <a16:creationId xmlns:a16="http://schemas.microsoft.com/office/drawing/2014/main" id="{66A82E18-22C5-ABBD-150C-603575AB908C}"/>
+                <a16:creationId xmlns:a16="http://schemas.microsoft.com/office/drawing/2014/main" id="{6CAF8B7C-1252-90C3-9609-E4F4F58850AD}"/>
               </a:ext>
             </a:extLst>
           </p:cNvPr>
@@ -5492,16 +5502,16 @@
         </p:spPr>
         <p:txBody>
           <a:bodyPr>
-            <a:normAutofit/>
+            <a:noAutofit/>
           </a:bodyPr>
           <a:lstStyle/>
           <a:p>
             <a:r>
-              <a:rPr lang="en-US" sz="1500"/>
+              <a:rPr lang="en-US" sz="1600"/>
               <a:t>A </a:t>
             </a:r>
             <a:r>
-              <a:rPr lang="en-US" sz="1500" b="1">
+              <a:rPr lang="en-US" sz="1600" b="1">
                 <a:solidFill>
                   <a:srgbClr val="C00000"/>
                 </a:solidFill>
@@ -5509,37 +5519,37 @@
               <a:t>cumulative distribution</a:t>
             </a:r>
             <a:r>
-              <a:rPr lang="en-US" sz="1500"/>
+              <a:rPr lang="en-US" sz="1600"/>
               <a:t> shows the relationship between the value of a variable and the cumulative relative frequency</a:t>
             </a:r>
           </a:p>
           <a:p>
             <a:r>
-              <a:rPr lang="en-US" sz="1500"/>
+              <a:rPr lang="en-US" sz="1600"/>
               <a:t>crf(x) answers one question: what fraction of the data falls at or below x?</a:t>
             </a:r>
           </a:p>
           <a:p>
             <a:pPr lvl="1"/>
             <a:r>
-              <a:rPr lang="en-US" sz="1500"/>
+              <a:rPr lang="en-US" sz="1600"/>
               <a:t>It only ever climbs - it can never come back down</a:t>
             </a:r>
           </a:p>
           <a:p>
             <a:pPr lvl="1"/>
             <a:r>
-              <a:rPr lang="en-US" sz="1500"/>
+              <a:rPr lang="en-US" sz="1600"/>
               <a:t>It starts at 0 and finishes at 1</a:t>
             </a:r>
           </a:p>
           <a:p>
             <a:r>
-              <a:rPr lang="en-US" sz="1500"/>
+              <a:rPr lang="en-US" sz="1600"/>
               <a:t>For discrete data we draw it as a </a:t>
             </a:r>
             <a:r>
-              <a:rPr lang="en-US" sz="1500" b="1">
+              <a:rPr lang="en-US" sz="1600" b="1">
                 <a:solidFill>
                   <a:srgbClr val="C00000"/>
                 </a:solidFill>
@@ -5547,14 +5557,14 @@
               <a:t>step function</a:t>
             </a:r>
             <a:r>
-              <a:rPr lang="en-US" sz="1500"/>
+              <a:rPr lang="en-US" sz="1600"/>
               <a:t>: flat between observed values, jumping at each one</a:t>
             </a:r>
           </a:p>
           <a:p>
             <a:pPr lvl="1"/>
             <a:r>
-              <a:rPr lang="en-US" sz="1500"/>
+              <a:rPr lang="en-US" sz="1600"/>
               <a:t>The height of a jump is that value’s relative frequency</a:t>
             </a:r>
           </a:p>
@@ -5565,7 +5575,7 @@
           <p:cNvPr id="4" name="Slide Number Placeholder 3">
             <a:extLst>
               <a:ext uri="{FF2B5EF4-FFF2-40B4-BE49-F238E27FC236}">
-                <a16:creationId xmlns:a16="http://schemas.microsoft.com/office/drawing/2014/main" id="{1BDA1DEC-B80C-DEA8-9E4B-F470100EF29C}"/>
+                <a16:creationId xmlns:a16="http://schemas.microsoft.com/office/drawing/2014/main" id="{94D79AE9-B3D5-D5ED-1F41-E067CC1FC027}"/>
               </a:ext>
             </a:extLst>
           </p:cNvPr>
@@ -5582,10 +5592,10 @@
           <a:lstStyle/>
           <a:p>
             <a:fld id="{A80A81DD-F10A-4B1C-963A-0ABBB4865886}" type="slidenum">
-              <a:rPr lang="en-US" smtClean="0"/>
+              <a:rPr lang="en-US" sz="1600" smtClean="0"/>
               <a:t>4</a:t>
             </a:fld>
-            <a:endParaRPr lang="en-US"/>
+            <a:endParaRPr lang="en-US" sz="1600"/>
           </a:p>
         </p:txBody>
       </p:sp>
@@ -5594,7 +5604,7 @@
           <p:cNvPr id="6" name="Picture 5">
             <a:extLst>
               <a:ext uri="{FF2B5EF4-FFF2-40B4-BE49-F238E27FC236}">
-                <a16:creationId xmlns:a16="http://schemas.microsoft.com/office/drawing/2014/main" id="{53AD31FB-0E25-762C-2703-2BFEC3AE3621}"/>
+                <a16:creationId xmlns:a16="http://schemas.microsoft.com/office/drawing/2014/main" id="{888EC700-1CEA-9CE2-6AD2-58F025AEB847}"/>
               </a:ext>
             </a:extLst>
           </p:cNvPr>
@@ -5630,7 +5640,7 @@
           <p:cNvPr id="5" name="Title rule">
             <a:extLst>
               <a:ext uri="{FF2B5EF4-FFF2-40B4-BE49-F238E27FC236}">
-                <a16:creationId xmlns:a16="http://schemas.microsoft.com/office/drawing/2014/main" id="{8B3F6397-317A-4CC5-66F2-2F6D145E6EB7}"/>
+                <a16:creationId xmlns:a16="http://schemas.microsoft.com/office/drawing/2014/main" id="{E0993F5D-2680-A42D-1B71-0BE5D0370A2C}"/>
               </a:ext>
             </a:extLst>
           </p:cNvPr>
@@ -5696,7 +5706,7 @@
     </p:spTree>
     <p:extLst>
       <p:ext uri="{BB962C8B-B14F-4D97-AF65-F5344CB8AC3E}">
-        <p14:creationId xmlns:p14="http://schemas.microsoft.com/office/powerpoint/2010/main" val="530570421"/>
+        <p14:creationId xmlns:p14="http://schemas.microsoft.com/office/powerpoint/2010/main" val="2472879935"/>
       </p:ext>
     </p:extLst>
   </p:cSld>
@@ -5728,7 +5738,7 @@
           <p:cNvPr id="2" name="Title 1">
             <a:extLst>
               <a:ext uri="{FF2B5EF4-FFF2-40B4-BE49-F238E27FC236}">
-                <a16:creationId xmlns:a16="http://schemas.microsoft.com/office/drawing/2014/main" id="{AD3FA2E3-CBA1-8469-AB37-A799F7CE7AE5}"/>
+                <a16:creationId xmlns:a16="http://schemas.microsoft.com/office/drawing/2014/main" id="{A3EBEB00-4340-CD49-E553-3E1FB69D9D6C}"/>
               </a:ext>
             </a:extLst>
           </p:cNvPr>
@@ -5741,7 +5751,9 @@
         </p:nvSpPr>
         <p:spPr/>
         <p:txBody>
-          <a:bodyPr/>
+          <a:bodyPr>
+            <a:noAutofit/>
+          </a:bodyPr>
           <a:lstStyle/>
           <a:p>
             <a:r>
@@ -5760,7 +5772,7 @@
           <p:cNvPr id="3" name="Content Placeholder 2">
             <a:extLst>
               <a:ext uri="{FF2B5EF4-FFF2-40B4-BE49-F238E27FC236}">
-                <a16:creationId xmlns:a16="http://schemas.microsoft.com/office/drawing/2014/main" id="{BDA162A7-6CF2-1E6D-C4C5-3B8459F54E39}"/>
+                <a16:creationId xmlns:a16="http://schemas.microsoft.com/office/drawing/2014/main" id="{CC286F7A-DDDE-1418-28CD-D778F57AAF42}"/>
               </a:ext>
             </a:extLst>
           </p:cNvPr>
@@ -5779,7 +5791,7 @@
         </p:spPr>
         <p:txBody>
           <a:bodyPr>
-            <a:normAutofit/>
+            <a:noAutofit/>
           </a:bodyPr>
           <a:lstStyle/>
           <a:p>
@@ -5813,7 +5825,7 @@
           <p:cNvPr id="4" name="Slide Number Placeholder 3">
             <a:extLst>
               <a:ext uri="{FF2B5EF4-FFF2-40B4-BE49-F238E27FC236}">
-                <a16:creationId xmlns:a16="http://schemas.microsoft.com/office/drawing/2014/main" id="{D6BCF3C2-7969-1D7D-4A17-00004E815372}"/>
+                <a16:creationId xmlns:a16="http://schemas.microsoft.com/office/drawing/2014/main" id="{12576739-13A3-C516-9A6E-E7364494596A}"/>
               </a:ext>
             </a:extLst>
           </p:cNvPr>
@@ -5830,10 +5842,10 @@
           <a:lstStyle/>
           <a:p>
             <a:fld id="{A80A81DD-F10A-4B1C-963A-0ABBB4865886}" type="slidenum">
-              <a:rPr lang="en-US" smtClean="0"/>
+              <a:rPr lang="en-US" sz="1600" smtClean="0"/>
               <a:t>5</a:t>
             </a:fld>
-            <a:endParaRPr lang="en-US"/>
+            <a:endParaRPr lang="en-US" sz="1600"/>
           </a:p>
         </p:txBody>
       </p:sp>
@@ -5842,7 +5854,7 @@
           <p:cNvPr id="6" name="Picture 5">
             <a:extLst>
               <a:ext uri="{FF2B5EF4-FFF2-40B4-BE49-F238E27FC236}">
-                <a16:creationId xmlns:a16="http://schemas.microsoft.com/office/drawing/2014/main" id="{1BCA98AD-F3A6-A2F7-C786-828587EDD0EA}"/>
+                <a16:creationId xmlns:a16="http://schemas.microsoft.com/office/drawing/2014/main" id="{B609F885-98A5-99AA-BF49-9EC9C272090B}"/>
               </a:ext>
             </a:extLst>
           </p:cNvPr>
@@ -5878,7 +5890,7 @@
           <p:cNvPr id="5" name="Title rule">
             <a:extLst>
               <a:ext uri="{FF2B5EF4-FFF2-40B4-BE49-F238E27FC236}">
-                <a16:creationId xmlns:a16="http://schemas.microsoft.com/office/drawing/2014/main" id="{F2D46C65-6ED7-7E33-ABF7-AA00F83C9767}"/>
+                <a16:creationId xmlns:a16="http://schemas.microsoft.com/office/drawing/2014/main" id="{E789064D-9C91-673C-AAAC-43F2E0278242}"/>
               </a:ext>
             </a:extLst>
           </p:cNvPr>
@@ -5944,7 +5956,7 @@
     </p:spTree>
     <p:extLst>
       <p:ext uri="{BB962C8B-B14F-4D97-AF65-F5344CB8AC3E}">
-        <p14:creationId xmlns:p14="http://schemas.microsoft.com/office/powerpoint/2010/main" val="3989403896"/>
+        <p14:creationId xmlns:p14="http://schemas.microsoft.com/office/powerpoint/2010/main" val="2977332096"/>
       </p:ext>
     </p:extLst>
   </p:cSld>
@@ -5976,7 +5988,7 @@
           <p:cNvPr id="2" name="Title 1">
             <a:extLst>
               <a:ext uri="{FF2B5EF4-FFF2-40B4-BE49-F238E27FC236}">
-                <a16:creationId xmlns:a16="http://schemas.microsoft.com/office/drawing/2014/main" id="{EF00490E-ED9D-847A-7A5B-4AE3845D082F}"/>
+                <a16:creationId xmlns:a16="http://schemas.microsoft.com/office/drawing/2014/main" id="{84D1646F-F959-CC5E-4B24-44E43E3A7BDD}"/>
               </a:ext>
             </a:extLst>
           </p:cNvPr>
@@ -5989,7 +6001,9 @@
         </p:nvSpPr>
         <p:spPr/>
         <p:txBody>
-          <a:bodyPr/>
+          <a:bodyPr>
+            <a:noAutofit/>
+          </a:bodyPr>
           <a:lstStyle/>
           <a:p>
             <a:r>
@@ -6008,7 +6022,7 @@
           <p:cNvPr id="3" name="Content Placeholder 2">
             <a:extLst>
               <a:ext uri="{FF2B5EF4-FFF2-40B4-BE49-F238E27FC236}">
-                <a16:creationId xmlns:a16="http://schemas.microsoft.com/office/drawing/2014/main" id="{E1740150-2EF1-43BA-3710-BAF7C0202588}"/>
+                <a16:creationId xmlns:a16="http://schemas.microsoft.com/office/drawing/2014/main" id="{F4CA91E0-F753-0421-D042-29DF16445BEB}"/>
               </a:ext>
             </a:extLst>
           </p:cNvPr>
@@ -6027,7 +6041,7 @@
         </p:spPr>
         <p:txBody>
           <a:bodyPr>
-            <a:normAutofit/>
+            <a:noAutofit/>
           </a:bodyPr>
           <a:lstStyle/>
           <a:p>
@@ -6088,7 +6102,7 @@
           <p:cNvPr id="4" name="Slide Number Placeholder 3">
             <a:extLst>
               <a:ext uri="{FF2B5EF4-FFF2-40B4-BE49-F238E27FC236}">
-                <a16:creationId xmlns:a16="http://schemas.microsoft.com/office/drawing/2014/main" id="{B4784FF2-74D9-2A02-089C-D5A80C261276}"/>
+                <a16:creationId xmlns:a16="http://schemas.microsoft.com/office/drawing/2014/main" id="{D3A00B64-83AD-F8AD-A71D-28B77BA7C467}"/>
               </a:ext>
             </a:extLst>
           </p:cNvPr>
@@ -6105,10 +6119,10 @@
           <a:lstStyle/>
           <a:p>
             <a:fld id="{A80A81DD-F10A-4B1C-963A-0ABBB4865886}" type="slidenum">
-              <a:rPr lang="en-US" smtClean="0"/>
+              <a:rPr lang="en-US" sz="1600" smtClean="0"/>
               <a:t>6</a:t>
             </a:fld>
-            <a:endParaRPr lang="en-US"/>
+            <a:endParaRPr lang="en-US" sz="1600"/>
           </a:p>
         </p:txBody>
       </p:sp>
@@ -6117,7 +6131,7 @@
           <p:cNvPr id="6" name="Picture 5">
             <a:extLst>
               <a:ext uri="{FF2B5EF4-FFF2-40B4-BE49-F238E27FC236}">
-                <a16:creationId xmlns:a16="http://schemas.microsoft.com/office/drawing/2014/main" id="{111F01EC-1C3D-ACBE-A3CA-B1415EDAD8AB}"/>
+                <a16:creationId xmlns:a16="http://schemas.microsoft.com/office/drawing/2014/main" id="{410CE912-8129-DA9C-DC30-EB617FC30368}"/>
               </a:ext>
             </a:extLst>
           </p:cNvPr>
@@ -6153,7 +6167,7 @@
           <p:cNvPr id="5" name="Title rule">
             <a:extLst>
               <a:ext uri="{FF2B5EF4-FFF2-40B4-BE49-F238E27FC236}">
-                <a16:creationId xmlns:a16="http://schemas.microsoft.com/office/drawing/2014/main" id="{1A9CC3A2-82FF-DBCE-EFAF-63620EB9A6CB}"/>
+                <a16:creationId xmlns:a16="http://schemas.microsoft.com/office/drawing/2014/main" id="{03F6EDD6-4698-838D-7ED2-9BAC208E36F7}"/>
               </a:ext>
             </a:extLst>
           </p:cNvPr>
@@ -6219,7 +6233,7 @@
     </p:spTree>
     <p:extLst>
       <p:ext uri="{BB962C8B-B14F-4D97-AF65-F5344CB8AC3E}">
-        <p14:creationId xmlns:p14="http://schemas.microsoft.com/office/powerpoint/2010/main" val="1259392583"/>
+        <p14:creationId xmlns:p14="http://schemas.microsoft.com/office/powerpoint/2010/main" val="1611422632"/>
       </p:ext>
     </p:extLst>
   </p:cSld>
@@ -6251,7 +6265,7 @@
           <p:cNvPr id="2" name="Title 1">
             <a:extLst>
               <a:ext uri="{FF2B5EF4-FFF2-40B4-BE49-F238E27FC236}">
-                <a16:creationId xmlns:a16="http://schemas.microsoft.com/office/drawing/2014/main" id="{CEC83FAD-4022-51C6-8B3C-13EF2F59A020}"/>
+                <a16:creationId xmlns:a16="http://schemas.microsoft.com/office/drawing/2014/main" id="{C2A942FD-EEA2-C7E4-F70A-F9FCF93D15CC}"/>
               </a:ext>
             </a:extLst>
           </p:cNvPr>
@@ -6264,7 +6278,9 @@
         </p:nvSpPr>
         <p:spPr/>
         <p:txBody>
-          <a:bodyPr/>
+          <a:bodyPr>
+            <a:noAutofit/>
+          </a:bodyPr>
           <a:lstStyle/>
           <a:p>
             <a:r>
@@ -6283,7 +6299,7 @@
           <p:cNvPr id="3" name="Content Placeholder 2">
             <a:extLst>
               <a:ext uri="{FF2B5EF4-FFF2-40B4-BE49-F238E27FC236}">
-                <a16:creationId xmlns:a16="http://schemas.microsoft.com/office/drawing/2014/main" id="{4BB836C9-F94E-A4E8-CC26-B583DA4CEBAF}"/>
+                <a16:creationId xmlns:a16="http://schemas.microsoft.com/office/drawing/2014/main" id="{CD6DDED9-400F-A9DC-839B-DFF9EDB0E4C5}"/>
               </a:ext>
             </a:extLst>
           </p:cNvPr>
@@ -6302,29 +6318,29 @@
         </p:spPr>
         <p:txBody>
           <a:bodyPr>
-            <a:normAutofit/>
+            <a:noAutofit/>
           </a:bodyPr>
           <a:lstStyle/>
           <a:p>
             <a:r>
-              <a:rPr lang="en-US" sz="1500"/>
+              <a:rPr lang="en-US" sz="1600"/>
               <a:t>Reading across at p usually crosses a jump, and the answer is that value</a:t>
             </a:r>
           </a:p>
           <a:p>
             <a:r>
-              <a:rPr lang="en-US" sz="1500"/>
+              <a:rPr lang="en-US" sz="1600"/>
               <a:t>But sometimes the line lands ON a flat run instead</a:t>
             </a:r>
           </a:p>
           <a:p>
             <a:pPr lvl="1"/>
             <a:r>
-              <a:rPr lang="en-US" sz="1500"/>
+              <a:rPr lang="en-US" sz="1600"/>
               <a:t>then the pth percentile is the </a:t>
             </a:r>
             <a:r>
-              <a:rPr lang="en-US" sz="1500" b="1">
+              <a:rPr lang="en-US" sz="1600" b="1">
                 <a:solidFill>
                   <a:srgbClr val="C00000"/>
                 </a:solidFill>
@@ -6332,33 +6348,33 @@
               <a:t>midpoint</a:t>
             </a:r>
             <a:r>
-              <a:rPr lang="en-US" sz="1500"/>
+              <a:rPr lang="en-US" sz="1600"/>
               <a:t> of that bar</a:t>
             </a:r>
           </a:p>
           <a:p>
             <a:r>
-              <a:rPr lang="en-US" sz="1500"/>
+              <a:rPr lang="en-US" sz="1600"/>
               <a:t>This happens when n is even, which is why n = 20 mattered</a:t>
             </a:r>
           </a:p>
           <a:p>
             <a:pPr lvl="1"/>
             <a:r>
-              <a:rPr lang="en-US" sz="1500"/>
+              <a:rPr lang="en-US" sz="1600"/>
               <a:t>crf reaches 0.90 exactly at x = 15, and the next value is 16</a:t>
             </a:r>
           </a:p>
           <a:p>
             <a:pPr lvl="1"/>
             <a:r>
-              <a:rPr lang="en-US" sz="1500"/>
+              <a:rPr lang="en-US" sz="1600"/>
               <a:t>so the 90th percentile is (15 + 16)/2 = 15.5, not 15</a:t>
             </a:r>
           </a:p>
           <a:p>
             <a:r>
-              <a:rPr lang="en-US" sz="1500"/>
+              <a:rPr lang="en-US" sz="1600"/>
               <a:t>Same story at 0.50 and 0.75, which is why Q2 = 9.5 and Q3 = 13</a:t>
             </a:r>
           </a:p>
@@ -6369,7 +6385,7 @@
           <p:cNvPr id="4" name="Slide Number Placeholder 3">
             <a:extLst>
               <a:ext uri="{FF2B5EF4-FFF2-40B4-BE49-F238E27FC236}">
-                <a16:creationId xmlns:a16="http://schemas.microsoft.com/office/drawing/2014/main" id="{26670901-E462-0EA1-6B4E-D9A73368C41F}"/>
+                <a16:creationId xmlns:a16="http://schemas.microsoft.com/office/drawing/2014/main" id="{810E148E-DFEA-E499-8D62-D1E844A9B9EB}"/>
               </a:ext>
             </a:extLst>
           </p:cNvPr>
@@ -6386,10 +6402,10 @@
           <a:lstStyle/>
           <a:p>
             <a:fld id="{A80A81DD-F10A-4B1C-963A-0ABBB4865886}" type="slidenum">
-              <a:rPr lang="en-US" smtClean="0"/>
+              <a:rPr lang="en-US" sz="1600" smtClean="0"/>
               <a:t>7</a:t>
             </a:fld>
-            <a:endParaRPr lang="en-US"/>
+            <a:endParaRPr lang="en-US" sz="1600"/>
           </a:p>
         </p:txBody>
       </p:sp>
@@ -6398,7 +6414,7 @@
           <p:cNvPr id="6" name="Picture 5">
             <a:extLst>
               <a:ext uri="{FF2B5EF4-FFF2-40B4-BE49-F238E27FC236}">
-                <a16:creationId xmlns:a16="http://schemas.microsoft.com/office/drawing/2014/main" id="{E29C5B87-E3DC-6252-C0B5-CC099CA8354D}"/>
+                <a16:creationId xmlns:a16="http://schemas.microsoft.com/office/drawing/2014/main" id="{0FB55158-6477-BDB9-13E6-87AA36C010DE}"/>
               </a:ext>
             </a:extLst>
           </p:cNvPr>
@@ -6434,7 +6450,7 @@
           <p:cNvPr id="5" name="Title rule">
             <a:extLst>
               <a:ext uri="{FF2B5EF4-FFF2-40B4-BE49-F238E27FC236}">
-                <a16:creationId xmlns:a16="http://schemas.microsoft.com/office/drawing/2014/main" id="{EF98FD5D-AA34-0E29-3B90-708EF024C178}"/>
+                <a16:creationId xmlns:a16="http://schemas.microsoft.com/office/drawing/2014/main" id="{1EB173A4-BB00-4273-C06A-4BBF631CFF98}"/>
               </a:ext>
             </a:extLst>
           </p:cNvPr>
@@ -6500,7 +6516,7 @@
     </p:spTree>
     <p:extLst>
       <p:ext uri="{BB962C8B-B14F-4D97-AF65-F5344CB8AC3E}">
-        <p14:creationId xmlns:p14="http://schemas.microsoft.com/office/powerpoint/2010/main" val="2880889777"/>
+        <p14:creationId xmlns:p14="http://schemas.microsoft.com/office/powerpoint/2010/main" val="1770664909"/>
       </p:ext>
     </p:extLst>
   </p:cSld>
@@ -6532,7 +6548,7 @@
           <p:cNvPr id="2" name="Title 1">
             <a:extLst>
               <a:ext uri="{FF2B5EF4-FFF2-40B4-BE49-F238E27FC236}">
-                <a16:creationId xmlns:a16="http://schemas.microsoft.com/office/drawing/2014/main" id="{97558C3A-0186-BE09-5612-4AB99573AFCF}"/>
+                <a16:creationId xmlns:a16="http://schemas.microsoft.com/office/drawing/2014/main" id="{E701A7D8-96C7-304E-EA25-87B2BEDADDBA}"/>
               </a:ext>
             </a:extLst>
           </p:cNvPr>
@@ -6545,7 +6561,9 @@
         </p:nvSpPr>
         <p:spPr/>
         <p:txBody>
-          <a:bodyPr/>
+          <a:bodyPr>
+            <a:noAutofit/>
+          </a:bodyPr>
           <a:lstStyle/>
           <a:p>
             <a:r>
@@ -6564,7 +6582,7 @@
           <p:cNvPr id="3" name="Content Placeholder 2">
             <a:extLst>
               <a:ext uri="{FF2B5EF4-FFF2-40B4-BE49-F238E27FC236}">
-                <a16:creationId xmlns:a16="http://schemas.microsoft.com/office/drawing/2014/main" id="{89F4EAD3-A82E-19CD-04B7-3E7A965CB622}"/>
+                <a16:creationId xmlns:a16="http://schemas.microsoft.com/office/drawing/2014/main" id="{2D931767-5F38-439A-8E3E-E26FE52CD09E}"/>
               </a:ext>
             </a:extLst>
           </p:cNvPr>
@@ -6583,7 +6601,7 @@
         </p:spPr>
         <p:txBody>
           <a:bodyPr>
-            <a:normAutofit/>
+            <a:noAutofit/>
           </a:bodyPr>
           <a:lstStyle/>
           <a:p>
@@ -6632,7 +6650,7 @@
           <p:cNvPr id="4" name="Slide Number Placeholder 3">
             <a:extLst>
               <a:ext uri="{FF2B5EF4-FFF2-40B4-BE49-F238E27FC236}">
-                <a16:creationId xmlns:a16="http://schemas.microsoft.com/office/drawing/2014/main" id="{855662BF-757C-093B-9441-D7D1839151E5}"/>
+                <a16:creationId xmlns:a16="http://schemas.microsoft.com/office/drawing/2014/main" id="{EB7EBE52-2046-AA02-7D1D-8D42472947A4}"/>
               </a:ext>
             </a:extLst>
           </p:cNvPr>
@@ -6649,10 +6667,10 @@
           <a:lstStyle/>
           <a:p>
             <a:fld id="{A80A81DD-F10A-4B1C-963A-0ABBB4865886}" type="slidenum">
-              <a:rPr lang="en-US" smtClean="0"/>
+              <a:rPr lang="en-US" sz="1600" smtClean="0"/>
               <a:t>8</a:t>
             </a:fld>
-            <a:endParaRPr lang="en-US"/>
+            <a:endParaRPr lang="en-US" sz="1600"/>
           </a:p>
         </p:txBody>
       </p:sp>
@@ -6661,7 +6679,7 @@
           <p:cNvPr id="6" name="Picture 5">
             <a:extLst>
               <a:ext uri="{FF2B5EF4-FFF2-40B4-BE49-F238E27FC236}">
-                <a16:creationId xmlns:a16="http://schemas.microsoft.com/office/drawing/2014/main" id="{913F9243-27C0-D14D-1039-B8CF8102D203}"/>
+                <a16:creationId xmlns:a16="http://schemas.microsoft.com/office/drawing/2014/main" id="{B49EBE77-41E7-6E41-5EB0-E591716DC333}"/>
               </a:ext>
             </a:extLst>
           </p:cNvPr>
@@ -6697,7 +6715,7 @@
           <p:cNvPr id="7" name="Rectangle: Rounded Corners 6">
             <a:extLst>
               <a:ext uri="{FF2B5EF4-FFF2-40B4-BE49-F238E27FC236}">
-                <a16:creationId xmlns:a16="http://schemas.microsoft.com/office/drawing/2014/main" id="{7BAB14AB-E1B6-BAE2-8571-BCBEEFF13731}"/>
+                <a16:creationId xmlns:a16="http://schemas.microsoft.com/office/drawing/2014/main" id="{7CB993E9-8D8E-85C3-4E13-AE7FB6417E40}"/>
               </a:ext>
             </a:extLst>
           </p:cNvPr>
@@ -6706,8 +6724,8 @@
         </p:nvSpPr>
         <p:spPr>
           <a:xfrm>
-            <a:off x="698500" y="4419600"/>
-            <a:ext cx="4699000" cy="1219200"/>
+            <a:off x="698500" y="4318000"/>
+            <a:ext cx="4826000" cy="1549400"/>
           </a:xfrm>
           <a:prstGeom prst="roundRect">
             <a:avLst>
@@ -6744,7 +6762,7 @@
           <a:lstStyle/>
           <a:p>
             <a:r>
-              <a:rPr lang="en-US" sz="1300" b="1">
+              <a:rPr lang="en-US" sz="1600" b="1">
                 <a:solidFill>
                   <a:srgbClr val="000000"/>
                 </a:solidFill>
@@ -6754,32 +6772,42 @@
           </a:p>
           <a:p>
             <a:r>
-              <a:rPr lang="en-US" sz="1300">
+              <a:rPr lang="en-US" sz="1600">
                 <a:solidFill>
                   <a:srgbClr val="000000"/>
                 </a:solidFill>
               </a:rPr>
-              <a:t>  11 g  -&gt;  crf = 0.65  -&gt;  65th percentile</a:t>
-            </a:r>
-          </a:p>
-          <a:p>
-            <a:r>
-              <a:rPr lang="en-US" sz="1300">
+              <a:t>11 g  -&gt;  crf = 0.65  -&gt;  65th percentile</a:t>
+            </a:r>
+          </a:p>
+          <a:p>
+            <a:r>
+              <a:rPr lang="en-US" sz="1600">
                 <a:solidFill>
                   <a:srgbClr val="000000"/>
                 </a:solidFill>
               </a:rPr>
-              <a:t>  5 g   -&gt;  crf = 0.35  -&gt;  35th percentile</a:t>
-            </a:r>
-          </a:p>
-          <a:p>
-            <a:r>
-              <a:rPr lang="en-US" sz="1300">
+              <a:t>5 g   -&gt;  crf = 0.35  -&gt;  35th percentile</a:t>
+            </a:r>
+          </a:p>
+          <a:p>
+            <a:r>
+              <a:rPr lang="en-US" sz="1600">
                 <a:solidFill>
                   <a:srgbClr val="000000"/>
                 </a:solidFill>
               </a:rPr>
-              <a:t>65% of these cereals have at most as much sugar as Honeycomb.</a:t>
+              <a:t>65% of cereals have at most</a:t>
+            </a:r>
+          </a:p>
+          <a:p>
+            <a:r>
+              <a:rPr lang="en-US" sz="1600">
+                <a:solidFill>
+                  <a:srgbClr val="000000"/>
+                </a:solidFill>
+              </a:rPr>
+              <a:t>as much sugar as Honeycomb.</a:t>
             </a:r>
           </a:p>
         </p:txBody>
@@ -6789,7 +6817,7 @@
           <p:cNvPr id="5" name="Title rule">
             <a:extLst>
               <a:ext uri="{FF2B5EF4-FFF2-40B4-BE49-F238E27FC236}">
-                <a16:creationId xmlns:a16="http://schemas.microsoft.com/office/drawing/2014/main" id="{9620AD36-DF8F-D110-C073-8CF9BA990649}"/>
+                <a16:creationId xmlns:a16="http://schemas.microsoft.com/office/drawing/2014/main" id="{29841CAD-0A64-1B7B-DF36-BC2501BE3E8F}"/>
               </a:ext>
             </a:extLst>
           </p:cNvPr>
@@ -6855,7 +6883,7 @@
     </p:spTree>
     <p:extLst>
       <p:ext uri="{BB962C8B-B14F-4D97-AF65-F5344CB8AC3E}">
-        <p14:creationId xmlns:p14="http://schemas.microsoft.com/office/powerpoint/2010/main" val="2397357209"/>
+        <p14:creationId xmlns:p14="http://schemas.microsoft.com/office/powerpoint/2010/main" val="3579474726"/>
       </p:ext>
     </p:extLst>
   </p:cSld>
@@ -7024,7 +7052,7 @@
           <p:cNvPr id="2" name="Title 1">
             <a:extLst>
               <a:ext uri="{FF2B5EF4-FFF2-40B4-BE49-F238E27FC236}">
-                <a16:creationId xmlns:a16="http://schemas.microsoft.com/office/drawing/2014/main" id="{4FE0D1D9-348F-4446-7BD4-FD16C7145D7E}"/>
+                <a16:creationId xmlns:a16="http://schemas.microsoft.com/office/drawing/2014/main" id="{7E64525B-1C77-EA82-0A0B-A12B880E6FE1}"/>
               </a:ext>
             </a:extLst>
           </p:cNvPr>
@@ -7037,7 +7065,9 @@
         </p:nvSpPr>
         <p:spPr/>
         <p:txBody>
-          <a:bodyPr/>
+          <a:bodyPr>
+            <a:noAutofit/>
+          </a:bodyPr>
           <a:lstStyle/>
           <a:p>
             <a:r>
@@ -7056,7 +7086,7 @@
           <p:cNvPr id="3" name="Content Placeholder 2">
             <a:extLst>
               <a:ext uri="{FF2B5EF4-FFF2-40B4-BE49-F238E27FC236}">
-                <a16:creationId xmlns:a16="http://schemas.microsoft.com/office/drawing/2014/main" id="{52ABE317-586B-726B-C9C8-C7E773AAF795}"/>
+                <a16:creationId xmlns:a16="http://schemas.microsoft.com/office/drawing/2014/main" id="{161373CF-5AED-DEB6-4EAB-A73F7F69B0E6}"/>
               </a:ext>
             </a:extLst>
           </p:cNvPr>
@@ -7075,7 +7105,7 @@
         </p:spPr>
         <p:txBody>
           <a:bodyPr>
-            <a:normAutofit/>
+            <a:noAutofit/>
           </a:bodyPr>
           <a:lstStyle/>
           <a:p>
@@ -7109,7 +7139,7 @@
           <p:cNvPr id="4" name="Slide Number Placeholder 3">
             <a:extLst>
               <a:ext uri="{FF2B5EF4-FFF2-40B4-BE49-F238E27FC236}">
-                <a16:creationId xmlns:a16="http://schemas.microsoft.com/office/drawing/2014/main" id="{38314768-F4A2-B208-47D1-992605A6B264}"/>
+                <a16:creationId xmlns:a16="http://schemas.microsoft.com/office/drawing/2014/main" id="{9205B9DF-6567-296A-AE14-10FC779F4307}"/>
               </a:ext>
             </a:extLst>
           </p:cNvPr>
@@ -7126,10 +7156,10 @@
           <a:lstStyle/>
           <a:p>
             <a:fld id="{A80A81DD-F10A-4B1C-963A-0ABBB4865886}" type="slidenum">
-              <a:rPr lang="en-US" smtClean="0"/>
+              <a:rPr lang="en-US" sz="1600" smtClean="0"/>
               <a:t>9</a:t>
             </a:fld>
-            <a:endParaRPr lang="en-US"/>
+            <a:endParaRPr lang="en-US" sz="1600"/>
           </a:p>
         </p:txBody>
       </p:sp>
@@ -7138,7 +7168,7 @@
           <p:cNvPr id="6" name="Picture 5">
             <a:extLst>
               <a:ext uri="{FF2B5EF4-FFF2-40B4-BE49-F238E27FC236}">
-                <a16:creationId xmlns:a16="http://schemas.microsoft.com/office/drawing/2014/main" id="{BC071396-6B9B-01C1-DEB9-FAFFB354993D}"/>
+                <a16:creationId xmlns:a16="http://schemas.microsoft.com/office/drawing/2014/main" id="{DE75E754-56EE-65D0-C82A-2B8B98EB6C9F}"/>
               </a:ext>
             </a:extLst>
           </p:cNvPr>
@@ -7174,7 +7204,7 @@
           <p:cNvPr id="8" name="Picture 7">
             <a:extLst>
               <a:ext uri="{FF2B5EF4-FFF2-40B4-BE49-F238E27FC236}">
-                <a16:creationId xmlns:a16="http://schemas.microsoft.com/office/drawing/2014/main" id="{B413B6DA-68D3-641B-9BDD-AC5E7EAB55B1}"/>
+                <a16:creationId xmlns:a16="http://schemas.microsoft.com/office/drawing/2014/main" id="{E620036E-6843-D09A-8282-9B31BC78FD4D}"/>
               </a:ext>
             </a:extLst>
           </p:cNvPr>
@@ -7210,7 +7240,7 @@
           <p:cNvPr id="5" name="Title rule">
             <a:extLst>
               <a:ext uri="{FF2B5EF4-FFF2-40B4-BE49-F238E27FC236}">
-                <a16:creationId xmlns:a16="http://schemas.microsoft.com/office/drawing/2014/main" id="{7DFD4820-74A0-3CDD-06E9-D3C8AE406898}"/>
+                <a16:creationId xmlns:a16="http://schemas.microsoft.com/office/drawing/2014/main" id="{755EA834-14FD-3A83-C622-3FA0FF4D8983}"/>
               </a:ext>
             </a:extLst>
           </p:cNvPr>
@@ -7276,7 +7306,7 @@
     </p:spTree>
     <p:extLst>
       <p:ext uri="{BB962C8B-B14F-4D97-AF65-F5344CB8AC3E}">
-        <p14:creationId xmlns:p14="http://schemas.microsoft.com/office/powerpoint/2010/main" val="571186987"/>
+        <p14:creationId xmlns:p14="http://schemas.microsoft.com/office/powerpoint/2010/main" val="2480599729"/>
       </p:ext>
     </p:extLst>
   </p:cSld>

</xml_diff>

<commit_message>
Expand Exam 1 review and Lecture 7 figures
Broadened the Exam 1 review source with new/clarified questions, added solution explanations (including quartile-method notes, display-type classification, and variance reasoning), and updated numbering/content in both student and solution outputs. Enhanced `docs/assets/make_lecture7_figures.R` to generate five new Lecture 7 visuals (sleep-table/cdf variants and shape-comparison panel) with additional consistency checks and rendering helpers. Regenerated related site artifacts (`.html`/`.pdf` pages, lecture PDFs, schedules, and data-table widget IDs) and updated the study guide to state that histogram/bin intervals are always provided.
</commit_message>
<xml_diff>
--- a/docs/lecture_slides/Week 3/Week3_Lecture7_Slides_9_11_2026.pptx
+++ b/docs/lecture_slides/Week 3/Week3_Lecture7_Slides_9_11_2026.pptx
@@ -6,17 +6,20 @@
   </p:sldMasterIdLst>
   <p:sldIdLst>
     <p:sldId id="256" r:id="rId2"/>
-    <p:sldId id="331" r:id="rId3"/>
-    <p:sldId id="332" r:id="rId4"/>
-    <p:sldId id="333" r:id="rId5"/>
-    <p:sldId id="334" r:id="rId6"/>
-    <p:sldId id="335" r:id="rId7"/>
-    <p:sldId id="336" r:id="rId8"/>
-    <p:sldId id="337" r:id="rId9"/>
-    <p:sldId id="338" r:id="rId10"/>
-    <p:sldId id="339" r:id="rId11"/>
-    <p:sldId id="340" r:id="rId12"/>
-    <p:sldId id="341" r:id="rId13"/>
+    <p:sldId id="257" r:id="rId3"/>
+    <p:sldId id="258" r:id="rId4"/>
+    <p:sldId id="259" r:id="rId5"/>
+    <p:sldId id="260" r:id="rId6"/>
+    <p:sldId id="261" r:id="rId7"/>
+    <p:sldId id="262" r:id="rId8"/>
+    <p:sldId id="263" r:id="rId9"/>
+    <p:sldId id="264" r:id="rId10"/>
+    <p:sldId id="265" r:id="rId11"/>
+    <p:sldId id="266" r:id="rId12"/>
+    <p:sldId id="267" r:id="rId13"/>
+    <p:sldId id="268" r:id="rId14"/>
+    <p:sldId id="269" r:id="rId15"/>
+    <p:sldId id="270" r:id="rId16"/>
   </p:sldIdLst>
   <p:sldSz cx="12192000" cy="6858000"/>
   <p:notesSz cx="6858000" cy="9144000"/>
@@ -3429,6 +3432,1392 @@
       </p:grpSpPr>
       <p:sp>
         <p:nvSpPr>
+          <p:cNvPr id="2" name="Title 1">
+            <a:extLst>
+              <a:ext uri="{FF2B5EF4-FFF2-40B4-BE49-F238E27FC236}">
+                <a16:creationId xmlns:a16="http://schemas.microsoft.com/office/drawing/2014/main" id="{7A1C4E30-2B55-4D71-9F02-113C77A0DA01}"/>
+              </a:ext>
+            </a:extLst>
+          </p:cNvPr>
+          <p:cNvSpPr>
+            <a:spLocks noGrp="1"/>
+          </p:cNvSpPr>
+          <p:nvPr>
+            <p:ph type="title"/>
+          </p:nvPr>
+        </p:nvSpPr>
+        <p:spPr/>
+        <p:txBody>
+          <a:bodyPr>
+            <a:noAutofit/>
+          </a:bodyPr>
+          <a:lstStyle/>
+          <a:p>
+            <a:r>
+              <a:rPr lang="en-US">
+                <a:solidFill>
+                  <a:srgbClr val="1F3864"/>
+                </a:solidFill>
+              </a:rPr>
+              <a:t>Your turn: build the table</a:t>
+            </a:r>
+          </a:p>
+        </p:txBody>
+      </p:sp>
+      <p:sp>
+        <p:nvSpPr>
+          <p:cNvPr id="3" name="Content Placeholder 2">
+            <a:extLst>
+              <a:ext uri="{FF2B5EF4-FFF2-40B4-BE49-F238E27FC236}">
+                <a16:creationId xmlns:a16="http://schemas.microsoft.com/office/drawing/2014/main" id="{7A1C4E30-2B55-4D71-9F02-113C77A0DA02}"/>
+              </a:ext>
+            </a:extLst>
+          </p:cNvPr>
+          <p:cNvSpPr>
+            <a:spLocks noGrp="1"/>
+          </p:cNvSpPr>
+          <p:nvPr>
+            <p:ph idx="1"/>
+          </p:nvPr>
+        </p:nvSpPr>
+        <p:spPr>
+          <a:xfrm>
+            <a:off x="635000" y="1879600"/>
+            <a:ext cx="4572000" cy="3810000"/>
+          </a:xfrm>
+        </p:spPr>
+        <p:txBody>
+          <a:bodyPr>
+            <a:noAutofit/>
+          </a:bodyPr>
+          <a:lstStyle/>
+          <a:p>
+            <a:r>
+              <a:rPr lang="en-US" sz="1600"/>
+              <a:t>Ten students were asked how many hours they slept last night:</a:t>
+            </a:r>
+          </a:p>
+          <a:p>
+            <a:pPr marL="0" indent="0">
+              <a:buNone/>
+            </a:pPr>
+            <a:r>
+              <a:rPr lang="en-US" sz="2000" b="1">
+                <a:solidFill>
+                  <a:srgbClr val="1F3864"/>
+                </a:solidFill>
+              </a:rPr>
+              <a:t>7    9    6    7    8    5    7    9    6    8</a:t>
+            </a:r>
+          </a:p>
+          <a:p>
+            <a:r>
+              <a:rPr lang="en-US" sz="1600"/>
+              <a:t>n = 10. Fill in the three missing columns:</a:t>
+            </a:r>
+          </a:p>
+          <a:p>
+            <a:pPr lvl="1"/>
+            <a:r>
+              <a:rPr lang="en-US" sz="1600"/>
+              <a:t>f(x) - how many times each value appears</a:t>
+            </a:r>
+          </a:p>
+          <a:p>
+            <a:pPr lvl="1"/>
+            <a:r>
+              <a:rPr lang="en-US" sz="1600"/>
+              <a:t>rf(x) - each count divided by n = 10</a:t>
+            </a:r>
+          </a:p>
+          <a:p>
+            <a:pPr lvl="1"/>
+            <a:r>
+              <a:rPr lang="en-US" sz="1600"/>
+              <a:t>crf(x) - the relative frequencies added up as you work down the column</a:t>
+            </a:r>
+          </a:p>
+          <a:p>
+            <a:r>
+              <a:rPr lang="en-US" sz="1600" b="1">
+                <a:solidFill>
+                  <a:srgbClr val="C00000"/>
+                </a:solidFill>
+              </a:rPr>
+              <a:t>The last crf has to come out at 1.00. If it does not, the counts are wrong.</a:t>
+            </a:r>
+          </a:p>
+        </p:txBody>
+      </p:sp>
+      <p:sp>
+        <p:nvSpPr>
+          <p:cNvPr id="4" name="Slide Number Placeholder 3">
+            <a:extLst>
+              <a:ext uri="{FF2B5EF4-FFF2-40B4-BE49-F238E27FC236}">
+                <a16:creationId xmlns:a16="http://schemas.microsoft.com/office/drawing/2014/main" id="{7A1C4E30-2B55-4D71-9F02-113C77A0DA03}"/>
+              </a:ext>
+            </a:extLst>
+          </p:cNvPr>
+          <p:cNvSpPr>
+            <a:spLocks noGrp="1"/>
+          </p:cNvSpPr>
+          <p:nvPr>
+            <p:ph type="sldNum" sz="quarter" idx="12"/>
+          </p:nvPr>
+        </p:nvSpPr>
+        <p:spPr/>
+        <p:txBody>
+          <a:bodyPr/>
+          <a:lstStyle/>
+          <a:p>
+            <a:fld id="{A80A81DD-F10A-4B1C-963A-0ABBB4865886}" type="slidenum">
+              <a:rPr lang="en-US" sz="1600" smtClean="0"/>
+              <a:t>10</a:t>
+            </a:fld>
+            <a:endParaRPr lang="en-US" sz="1600"/>
+          </a:p>
+        </p:txBody>
+      </p:sp>
+      <p:pic>
+        <p:nvPicPr>
+          <p:cNvPr id="6" name="Picture 5">
+            <a:extLst>
+              <a:ext uri="{FF2B5EF4-FFF2-40B4-BE49-F238E27FC236}">
+                <a16:creationId xmlns:a16="http://schemas.microsoft.com/office/drawing/2014/main" id="{7A1C4E30-2B55-4D71-9F02-113C77A0DA06}"/>
+              </a:ext>
+            </a:extLst>
+          </p:cNvPr>
+          <p:cNvPicPr>
+            <a:picLocks/>
+          </p:cNvPicPr>
+          <p:nvPr/>
+        </p:nvPicPr>
+        <p:blipFill>
+          <a:blip r:embed="rId2">
+            <a:extLst>
+              <a:ext uri="{28A0092B-C50C-407E-A947-70E740481C1C}">
+                <a14:useLocalDpi xmlns:a14="http://schemas.microsoft.com/office/drawing/2010/main" val="0"/>
+              </a:ext>
+            </a:extLst>
+          </a:blip>
+          <a:stretch>
+            <a:fillRect/>
+          </a:stretch>
+        </p:blipFill>
+        <p:spPr>
+          <a:xfrm>
+            <a:off x="5461000" y="2408150"/>
+            <a:ext cx="6223000" cy="2933700"/>
+          </a:xfrm>
+          <a:prstGeom prst="rect">
+            <a:avLst/>
+          </a:prstGeom>
+        </p:spPr>
+      </p:pic>
+      <p:pic>
+        <p:nvPicPr>
+          <p:cNvPr id="8" name="Picture 7">
+            <a:extLst>
+              <a:ext uri="{FF2B5EF4-FFF2-40B4-BE49-F238E27FC236}">
+                <a16:creationId xmlns:a16="http://schemas.microsoft.com/office/drawing/2014/main" id="{7A1C4E30-2B55-4D71-9F02-113C77A0DA08}"/>
+              </a:ext>
+            </a:extLst>
+          </p:cNvPr>
+          <p:cNvPicPr>
+            <a:picLocks/>
+          </p:cNvPicPr>
+          <p:nvPr/>
+        </p:nvPicPr>
+        <p:blipFill>
+          <a:blip r:embed="rId3">
+            <a:extLst>
+              <a:ext uri="{28A0092B-C50C-407E-A947-70E740481C1C}">
+                <a14:useLocalDpi xmlns:a14="http://schemas.microsoft.com/office/drawing/2010/main" val="0"/>
+              </a:ext>
+            </a:extLst>
+          </a:blip>
+          <a:stretch>
+            <a:fillRect/>
+          </a:stretch>
+        </p:blipFill>
+        <p:spPr>
+          <a:xfrm>
+            <a:off x="5461000" y="2408150"/>
+            <a:ext cx="6223000" cy="2933700"/>
+          </a:xfrm>
+          <a:prstGeom prst="rect">
+            <a:avLst/>
+          </a:prstGeom>
+        </p:spPr>
+      </p:pic>
+      <p:sp>
+        <p:nvSpPr>
+          <p:cNvPr id="5" name="Title rule">
+            <a:extLst>
+              <a:ext uri="{FF2B5EF4-FFF2-40B4-BE49-F238E27FC236}">
+                <a16:creationId xmlns:a16="http://schemas.microsoft.com/office/drawing/2014/main" id="{7A1C4E30-2B55-4D71-9F02-113C77A0DA05}"/>
+              </a:ext>
+            </a:extLst>
+          </p:cNvPr>
+          <p:cNvSpPr/>
+          <p:nvPr/>
+        </p:nvSpPr>
+        <p:spPr>
+          <a:xfrm>
+            <a:off x="838200" y="1600200"/>
+            <a:ext cx="10515600" cy="38100"/>
+          </a:xfrm>
+          <a:prstGeom prst="rect">
+            <a:avLst/>
+          </a:prstGeom>
+          <a:solidFill>
+            <a:srgbClr val="4472C4"/>
+          </a:solidFill>
+          <a:ln w="12700" cap="flat" cmpd="sng" algn="ctr">
+            <a:noFill/>
+            <a:prstDash val="solid"/>
+            <a:miter lim="800000"/>
+          </a:ln>
+          <a:effectLst/>
+        </p:spPr>
+        <p:style>
+          <a:lnRef idx="2">
+            <a:schemeClr val="accent1">
+              <a:shade val="15000"/>
+            </a:schemeClr>
+          </a:lnRef>
+          <a:fillRef idx="1">
+            <a:schemeClr val="accent1"/>
+          </a:fillRef>
+          <a:effectRef idx="0">
+            <a:schemeClr val="accent1"/>
+          </a:effectRef>
+          <a:fontRef idx="minor">
+            <a:schemeClr val="lt1"/>
+          </a:fontRef>
+        </p:style>
+        <p:txBody>
+          <a:bodyPr rtlCol="0" anchor="ctr"/>
+          <a:lstStyle/>
+          <a:p>
+            <a:pPr algn="ctr"/>
+            <a:endParaRPr lang="en-US"/>
+          </a:p>
+        </p:txBody>
+      </p:sp>
+    </p:spTree>
+    <p:extLst>
+      <p:ext uri="{BB962C8B-B14F-4D97-AF65-F5344CB8AC3E}">
+        <p14:creationId xmlns:p14="http://schemas.microsoft.com/office/powerpoint/2010/main" val="1697533710"/>
+      </p:ext>
+    </p:extLst>
+  </p:cSld>
+  <p:clrMapOvr>
+    <a:masterClrMapping/>
+  </p:clrMapOvr>
+  <p:timing>
+    <p:tnLst>
+      <p:par>
+        <p:cTn id="1" dur="indefinite" restart="never" nodeType="tmRoot">
+          <p:childTnLst>
+            <p:seq concurrent="1" nextAc="seek">
+              <p:cTn id="2" dur="indefinite" nodeType="mainSeq">
+                <p:childTnLst>
+                  <p:par>
+                    <p:cTn id="3" fill="hold">
+                      <p:stCondLst>
+                        <p:cond delay="indefinite"/>
+                      </p:stCondLst>
+                      <p:childTnLst>
+                        <p:par>
+                          <p:cTn id="4" fill="hold">
+                            <p:stCondLst>
+                              <p:cond delay="0"/>
+                            </p:stCondLst>
+                            <p:childTnLst>
+                              <p:par>
+                                <p:cTn id="5" presetID="34" presetClass="entr" presetSubtype="0" fill="hold" nodeType="clickEffect">
+                                  <p:stCondLst>
+                                    <p:cond delay="0"/>
+                                  </p:stCondLst>
+                                  <p:childTnLst>
+                                    <p:set>
+                                      <p:cBhvr>
+                                        <p:cTn id="6" dur="1" fill="hold">
+                                          <p:stCondLst>
+                                            <p:cond delay="0"/>
+                                          </p:stCondLst>
+                                        </p:cTn>
+                                        <p:tgtEl>
+                                          <p:spTgt spid="8"/>
+                                        </p:tgtEl>
+                                        <p:attrNameLst>
+                                          <p:attrName>style.visibility</p:attrName>
+                                        </p:attrNameLst>
+                                      </p:cBhvr>
+                                      <p:to>
+                                        <p:strVal val="visible"/>
+                                      </p:to>
+                                    </p:set>
+                                    <p:anim from="(-#ppt_w/2)" to="(#ppt_x)" calcmode="lin" valueType="num">
+                                      <p:cBhvr>
+                                        <p:cTn id="7" dur="600" fill="hold">
+                                          <p:stCondLst>
+                                            <p:cond delay="0"/>
+                                          </p:stCondLst>
+                                        </p:cTn>
+                                        <p:tgtEl>
+                                          <p:spTgt spid="8"/>
+                                        </p:tgtEl>
+                                        <p:attrNameLst>
+                                          <p:attrName>ppt_x</p:attrName>
+                                        </p:attrNameLst>
+                                      </p:cBhvr>
+                                    </p:anim>
+                                    <p:anim from="0" to="-1.0" calcmode="lin" valueType="num">
+                                      <p:cBhvr>
+                                        <p:cTn id="8" dur="200" decel="50000" autoRev="1" fill="hold">
+                                          <p:stCondLst>
+                                            <p:cond delay="600"/>
+                                          </p:stCondLst>
+                                        </p:cTn>
+                                        <p:tgtEl>
+                                          <p:spTgt spid="8"/>
+                                        </p:tgtEl>
+                                        <p:attrNameLst>
+                                          <p:attrName>xshear</p:attrName>
+                                        </p:attrNameLst>
+                                      </p:cBhvr>
+                                    </p:anim>
+                                    <p:animScale>
+                                      <p:cBhvr>
+                                        <p:cTn id="9" dur="200" decel="100000" autoRev="1" fill="hold">
+                                          <p:stCondLst>
+                                            <p:cond delay="600"/>
+                                          </p:stCondLst>
+                                        </p:cTn>
+                                        <p:tgtEl>
+                                          <p:spTgt spid="8"/>
+                                        </p:tgtEl>
+                                      </p:cBhvr>
+                                      <p:from x="100000" y="100000"/>
+                                      <p:to x="80000" y="100000"/>
+                                    </p:animScale>
+                                    <p:anim by="(#ppt_h/3+#ppt_w*0.1)" calcmode="lin" valueType="num">
+                                      <p:cBhvr additive="sum">
+                                        <p:cTn id="10" dur="200" decel="100000" autoRev="1" fill="hold">
+                                          <p:stCondLst>
+                                            <p:cond delay="600"/>
+                                          </p:stCondLst>
+                                        </p:cTn>
+                                        <p:tgtEl>
+                                          <p:spTgt spid="8"/>
+                                        </p:tgtEl>
+                                        <p:attrNameLst>
+                                          <p:attrName>ppt_x</p:attrName>
+                                        </p:attrNameLst>
+                                      </p:cBhvr>
+                                    </p:anim>
+                                  </p:childTnLst>
+                                </p:cTn>
+                              </p:par>
+                            </p:childTnLst>
+                          </p:cTn>
+                        </p:par>
+                      </p:childTnLst>
+                    </p:cTn>
+                  </p:par>
+                </p:childTnLst>
+              </p:cTn>
+              <p:prevCondLst>
+                <p:cond evt="onPrev" delay="0">
+                  <p:tgtEl>
+                    <p:sldTgt/>
+                  </p:tgtEl>
+                </p:cond>
+              </p:prevCondLst>
+              <p:nextCondLst>
+                <p:cond evt="onNext" delay="0">
+                  <p:tgtEl>
+                    <p:sldTgt/>
+                  </p:tgtEl>
+                </p:cond>
+              </p:nextCondLst>
+            </p:seq>
+          </p:childTnLst>
+        </p:cTn>
+      </p:par>
+    </p:tnLst>
+  </p:timing>
+</p:sld>
+</file>
+
+<file path=ppt/slides/slide11.xml><?xml version="1.0" encoding="utf-8"?>
+<p:sld xmlns:a="http://schemas.openxmlformats.org/drawingml/2006/main" xmlns:r="http://schemas.openxmlformats.org/officeDocument/2006/relationships" xmlns:p="http://schemas.openxmlformats.org/presentationml/2006/main">
+  <p:cSld>
+    <p:spTree>
+      <p:nvGrpSpPr>
+        <p:cNvPr id="1" name=""/>
+        <p:cNvGrpSpPr/>
+        <p:nvPr/>
+      </p:nvGrpSpPr>
+      <p:grpSpPr>
+        <a:xfrm>
+          <a:off x="0" y="0"/>
+          <a:ext cx="0" cy="0"/>
+          <a:chOff x="0" y="0"/>
+          <a:chExt cx="0" cy="0"/>
+        </a:xfrm>
+      </p:grpSpPr>
+      <p:sp>
+        <p:nvSpPr>
+          <p:cNvPr id="2" name="Title 1">
+            <a:extLst>
+              <a:ext uri="{FF2B5EF4-FFF2-40B4-BE49-F238E27FC236}">
+                <a16:creationId xmlns:a16="http://schemas.microsoft.com/office/drawing/2014/main" id="{7A1C4E30-2B55-4D71-9F02-113C77A0DB01}"/>
+              </a:ext>
+            </a:extLst>
+          </p:cNvPr>
+          <p:cNvSpPr>
+            <a:spLocks noGrp="1"/>
+          </p:cNvSpPr>
+          <p:nvPr>
+            <p:ph type="title"/>
+          </p:nvPr>
+        </p:nvSpPr>
+        <p:spPr/>
+        <p:txBody>
+          <a:bodyPr>
+            <a:noAutofit/>
+          </a:bodyPr>
+          <a:lstStyle/>
+          <a:p>
+            <a:r>
+              <a:rPr lang="en-US">
+                <a:solidFill>
+                  <a:srgbClr val="1F3864"/>
+                </a:solidFill>
+              </a:rPr>
+              <a:t>Your turn: read the plot</a:t>
+            </a:r>
+          </a:p>
+        </p:txBody>
+      </p:sp>
+      <p:sp>
+        <p:nvSpPr>
+          <p:cNvPr id="3" name="Content Placeholder 2">
+            <a:extLst>
+              <a:ext uri="{FF2B5EF4-FFF2-40B4-BE49-F238E27FC236}">
+                <a16:creationId xmlns:a16="http://schemas.microsoft.com/office/drawing/2014/main" id="{7A1C4E30-2B55-4D71-9F02-113C77A0DB02}"/>
+              </a:ext>
+            </a:extLst>
+          </p:cNvPr>
+          <p:cNvSpPr>
+            <a:spLocks noGrp="1"/>
+          </p:cNvSpPr>
+          <p:nvPr>
+            <p:ph idx="1"/>
+          </p:nvPr>
+        </p:nvSpPr>
+        <p:spPr>
+          <a:xfrm>
+            <a:off x="635000" y="1879600"/>
+            <a:ext cx="4572000" cy="3810000"/>
+          </a:xfrm>
+        </p:spPr>
+        <p:txBody>
+          <a:bodyPr>
+            <a:noAutofit/>
+          </a:bodyPr>
+          <a:lstStyle/>
+          <a:p>
+            <a:r>
+              <a:rPr lang="en-US" sz="1600"/>
+              <a:t>Sketch the step plot from your table. Then read off:</a:t>
+            </a:r>
+          </a:p>
+          <a:p>
+            <a:pPr lvl="1"/>
+            <a:r>
+              <a:rPr lang="en-US" sz="1600"/>
+              <a:t>Q1, Q2 and Q3 - and then the IQR</a:t>
+            </a:r>
+          </a:p>
+          <a:p>
+            <a:pPr lvl="1"/>
+            <a:r>
+              <a:rPr lang="en-US" sz="1600"/>
+              <a:t>the 80th percentile - careful, look at where the bar sits</a:t>
+            </a:r>
+          </a:p>
+          <a:p>
+            <a:pPr lvl="1"/>
+            <a:r>
+              <a:rPr lang="en-US" sz="1600"/>
+              <a:t>one student slept 5 hours. What percentile is that?</a:t>
+            </a:r>
+          </a:p>
+        </p:txBody>
+      </p:sp>
+      <p:sp>
+        <p:nvSpPr>
+          <p:cNvPr id="4" name="Slide Number Placeholder 3">
+            <a:extLst>
+              <a:ext uri="{FF2B5EF4-FFF2-40B4-BE49-F238E27FC236}">
+                <a16:creationId xmlns:a16="http://schemas.microsoft.com/office/drawing/2014/main" id="{7A1C4E30-2B55-4D71-9F02-113C77A0DB03}"/>
+              </a:ext>
+            </a:extLst>
+          </p:cNvPr>
+          <p:cNvSpPr>
+            <a:spLocks noGrp="1"/>
+          </p:cNvSpPr>
+          <p:nvPr>
+            <p:ph type="sldNum" sz="quarter" idx="12"/>
+          </p:nvPr>
+        </p:nvSpPr>
+        <p:spPr/>
+        <p:txBody>
+          <a:bodyPr/>
+          <a:lstStyle/>
+          <a:p>
+            <a:fld id="{A80A81DD-F10A-4B1C-963A-0ABBB4865886}" type="slidenum">
+              <a:rPr lang="en-US" sz="1600" smtClean="0"/>
+              <a:t>11</a:t>
+            </a:fld>
+            <a:endParaRPr lang="en-US" sz="1600"/>
+          </a:p>
+        </p:txBody>
+      </p:sp>
+      <p:pic>
+        <p:nvPicPr>
+          <p:cNvPr id="6" name="Picture 5">
+            <a:extLst>
+              <a:ext uri="{FF2B5EF4-FFF2-40B4-BE49-F238E27FC236}">
+                <a16:creationId xmlns:a16="http://schemas.microsoft.com/office/drawing/2014/main" id="{7A1C4E30-2B55-4D71-9F02-113C77A0DB06}"/>
+              </a:ext>
+            </a:extLst>
+          </p:cNvPr>
+          <p:cNvPicPr>
+            <a:picLocks/>
+          </p:cNvPicPr>
+          <p:nvPr/>
+        </p:nvPicPr>
+        <p:blipFill>
+          <a:blip r:embed="rId2">
+            <a:extLst>
+              <a:ext uri="{28A0092B-C50C-407E-A947-70E740481C1C}">
+                <a14:useLocalDpi xmlns:a14="http://schemas.microsoft.com/office/drawing/2010/main" val="0"/>
+              </a:ext>
+            </a:extLst>
+          </a:blip>
+          <a:stretch>
+            <a:fillRect/>
+          </a:stretch>
+        </p:blipFill>
+        <p:spPr>
+          <a:xfrm>
+            <a:off x="5461000" y="1778000"/>
+            <a:ext cx="6223000" cy="3889375"/>
+          </a:xfrm>
+          <a:prstGeom prst="rect">
+            <a:avLst/>
+          </a:prstGeom>
+        </p:spPr>
+      </p:pic>
+      <p:pic>
+        <p:nvPicPr>
+          <p:cNvPr id="8" name="Picture 7">
+            <a:extLst>
+              <a:ext uri="{FF2B5EF4-FFF2-40B4-BE49-F238E27FC236}">
+                <a16:creationId xmlns:a16="http://schemas.microsoft.com/office/drawing/2014/main" id="{7A1C4E30-2B55-4D71-9F02-113C77A0DB08}"/>
+              </a:ext>
+            </a:extLst>
+          </p:cNvPr>
+          <p:cNvPicPr>
+            <a:picLocks/>
+          </p:cNvPicPr>
+          <p:nvPr/>
+        </p:nvPicPr>
+        <p:blipFill>
+          <a:blip r:embed="rId3">
+            <a:extLst>
+              <a:ext uri="{28A0092B-C50C-407E-A947-70E740481C1C}">
+                <a14:useLocalDpi xmlns:a14="http://schemas.microsoft.com/office/drawing/2010/main" val="0"/>
+              </a:ext>
+            </a:extLst>
+          </a:blip>
+          <a:stretch>
+            <a:fillRect/>
+          </a:stretch>
+        </p:blipFill>
+        <p:spPr>
+          <a:xfrm>
+            <a:off x="5461000" y="1778000"/>
+            <a:ext cx="6223000" cy="3889375"/>
+          </a:xfrm>
+          <a:prstGeom prst="rect">
+            <a:avLst/>
+          </a:prstGeom>
+        </p:spPr>
+      </p:pic>
+      <p:sp>
+        <p:nvSpPr>
+          <p:cNvPr id="7" name="Rectangle: Rounded Corners 6">
+            <a:extLst>
+              <a:ext uri="{FF2B5EF4-FFF2-40B4-BE49-F238E27FC236}">
+                <a16:creationId xmlns:a16="http://schemas.microsoft.com/office/drawing/2014/main" id="{7A1C4E30-2B55-4D71-9F02-113C77A0DB07}"/>
+              </a:ext>
+            </a:extLst>
+          </p:cNvPr>
+          <p:cNvSpPr/>
+          <p:nvPr/>
+        </p:nvSpPr>
+        <p:spPr>
+          <a:xfrm>
+            <a:off x="698500" y="4318000"/>
+            <a:ext cx="4826000" cy="1549400"/>
+          </a:xfrm>
+          <a:prstGeom prst="roundRect">
+            <a:avLst>
+              <a:gd name="adj" fmla="val 4000"/>
+            </a:avLst>
+          </a:prstGeom>
+          <a:solidFill>
+            <a:srgbClr val="F2F6FC"/>
+          </a:solidFill>
+          <a:ln w="15875">
+            <a:solidFill>
+              <a:srgbClr val="4472C4"/>
+            </a:solidFill>
+          </a:ln>
+        </p:spPr>
+        <p:style>
+          <a:lnRef idx="2">
+            <a:schemeClr val="accent1">
+              <a:shade val="15000"/>
+            </a:schemeClr>
+          </a:lnRef>
+          <a:fillRef idx="1">
+            <a:schemeClr val="accent1"/>
+          </a:fillRef>
+          <a:effectRef idx="0">
+            <a:schemeClr val="accent1"/>
+          </a:effectRef>
+          <a:fontRef idx="minor">
+            <a:schemeClr val="lt1"/>
+          </a:fontRef>
+        </p:style>
+        <p:txBody>
+          <a:bodyPr wrap="square" lIns="127000" tIns="63500" rIns="127000" bIns="63500" rtlCol="0" anchor="ctr"/>
+          <a:lstStyle/>
+          <a:p>
+            <a:r>
+              <a:rPr lang="en-US" sz="1600" b="1">
+                <a:solidFill>
+                  <a:srgbClr val="000000"/>
+                </a:solidFill>
+              </a:rPr>
+              <a:t>Working:</a:t>
+            </a:r>
+          </a:p>
+          <a:p>
+            <a:r>
+              <a:rPr lang="en-US" sz="1600">
+                <a:solidFill>
+                  <a:srgbClr val="000000"/>
+                </a:solidFill>
+              </a:rPr>
+              <a:t>Q1 = 6    Q2 = 7    Q3 = 8    IQR = 2</a:t>
+            </a:r>
+          </a:p>
+          <a:p>
+            <a:r>
+              <a:rPr lang="en-US" sz="1600">
+                <a:solidFill>
+                  <a:srgbClr val="000000"/>
+                </a:solidFill>
+              </a:rPr>
+              <a:t>crf sits exactly on 0.80 at x = 8, so the</a:t>
+            </a:r>
+          </a:p>
+          <a:p>
+            <a:r>
+              <a:rPr lang="en-US" sz="1600">
+                <a:solidFill>
+                  <a:srgbClr val="000000"/>
+                </a:solidFill>
+              </a:rPr>
+              <a:t>80th percentile is (8 + 9)/2 = 8.5</a:t>
+            </a:r>
+          </a:p>
+          <a:p>
+            <a:r>
+              <a:rPr lang="en-US" sz="1600">
+                <a:solidFill>
+                  <a:srgbClr val="000000"/>
+                </a:solidFill>
+              </a:rPr>
+              <a:t>5 hours  -&gt;  crf = 0.10  -&gt;  10th percentile</a:t>
+            </a:r>
+          </a:p>
+        </p:txBody>
+      </p:sp>
+      <p:sp>
+        <p:nvSpPr>
+          <p:cNvPr id="5" name="Title rule">
+            <a:extLst>
+              <a:ext uri="{FF2B5EF4-FFF2-40B4-BE49-F238E27FC236}">
+                <a16:creationId xmlns:a16="http://schemas.microsoft.com/office/drawing/2014/main" id="{7A1C4E30-2B55-4D71-9F02-113C77A0DB05}"/>
+              </a:ext>
+            </a:extLst>
+          </p:cNvPr>
+          <p:cNvSpPr/>
+          <p:nvPr/>
+        </p:nvSpPr>
+        <p:spPr>
+          <a:xfrm>
+            <a:off x="838200" y="1600200"/>
+            <a:ext cx="10515600" cy="38100"/>
+          </a:xfrm>
+          <a:prstGeom prst="rect">
+            <a:avLst/>
+          </a:prstGeom>
+          <a:solidFill>
+            <a:srgbClr val="4472C4"/>
+          </a:solidFill>
+          <a:ln w="12700" cap="flat" cmpd="sng" algn="ctr">
+            <a:noFill/>
+            <a:prstDash val="solid"/>
+            <a:miter lim="800000"/>
+          </a:ln>
+          <a:effectLst/>
+        </p:spPr>
+        <p:style>
+          <a:lnRef idx="2">
+            <a:schemeClr val="accent1">
+              <a:shade val="15000"/>
+            </a:schemeClr>
+          </a:lnRef>
+          <a:fillRef idx="1">
+            <a:schemeClr val="accent1"/>
+          </a:fillRef>
+          <a:effectRef idx="0">
+            <a:schemeClr val="accent1"/>
+          </a:effectRef>
+          <a:fontRef idx="minor">
+            <a:schemeClr val="lt1"/>
+          </a:fontRef>
+        </p:style>
+        <p:txBody>
+          <a:bodyPr rtlCol="0" anchor="ctr"/>
+          <a:lstStyle/>
+          <a:p>
+            <a:pPr algn="ctr"/>
+            <a:endParaRPr lang="en-US"/>
+          </a:p>
+        </p:txBody>
+      </p:sp>
+    </p:spTree>
+    <p:extLst>
+      <p:ext uri="{BB962C8B-B14F-4D97-AF65-F5344CB8AC3E}">
+        <p14:creationId xmlns:p14="http://schemas.microsoft.com/office/powerpoint/2010/main" val="1697533711"/>
+      </p:ext>
+    </p:extLst>
+  </p:cSld>
+  <p:clrMapOvr>
+    <a:masterClrMapping/>
+  </p:clrMapOvr>
+  <p:timing>
+    <p:tnLst>
+      <p:par>
+        <p:cTn id="1" dur="indefinite" restart="never" nodeType="tmRoot">
+          <p:childTnLst>
+            <p:seq concurrent="1" nextAc="seek">
+              <p:cTn id="2" dur="indefinite" nodeType="mainSeq">
+                <p:childTnLst>
+                  <p:par>
+                    <p:cTn id="3" fill="hold">
+                      <p:stCondLst>
+                        <p:cond delay="indefinite"/>
+                      </p:stCondLst>
+                      <p:childTnLst>
+                        <p:par>
+                          <p:cTn id="4" fill="hold">
+                            <p:stCondLst>
+                              <p:cond delay="0"/>
+                            </p:stCondLst>
+                            <p:childTnLst>
+                              <p:par>
+                                <p:cTn id="5" presetID="34" presetClass="entr" presetSubtype="0" fill="hold" nodeType="clickEffect">
+                                  <p:stCondLst>
+                                    <p:cond delay="0"/>
+                                  </p:stCondLst>
+                                  <p:childTnLst>
+                                    <p:set>
+                                      <p:cBhvr>
+                                        <p:cTn id="6" dur="1" fill="hold">
+                                          <p:stCondLst>
+                                            <p:cond delay="0"/>
+                                          </p:stCondLst>
+                                        </p:cTn>
+                                        <p:tgtEl>
+                                          <p:spTgt spid="6"/>
+                                        </p:tgtEl>
+                                        <p:attrNameLst>
+                                          <p:attrName>style.visibility</p:attrName>
+                                        </p:attrNameLst>
+                                      </p:cBhvr>
+                                      <p:to>
+                                        <p:strVal val="visible"/>
+                                      </p:to>
+                                    </p:set>
+                                    <p:anim from="(-#ppt_w/2)" to="(#ppt_x)" calcmode="lin" valueType="num">
+                                      <p:cBhvr>
+                                        <p:cTn id="7" dur="600" fill="hold">
+                                          <p:stCondLst>
+                                            <p:cond delay="0"/>
+                                          </p:stCondLst>
+                                        </p:cTn>
+                                        <p:tgtEl>
+                                          <p:spTgt spid="6"/>
+                                        </p:tgtEl>
+                                        <p:attrNameLst>
+                                          <p:attrName>ppt_x</p:attrName>
+                                        </p:attrNameLst>
+                                      </p:cBhvr>
+                                    </p:anim>
+                                    <p:anim from="0" to="-1.0" calcmode="lin" valueType="num">
+                                      <p:cBhvr>
+                                        <p:cTn id="8" dur="200" decel="50000" autoRev="1" fill="hold">
+                                          <p:stCondLst>
+                                            <p:cond delay="600"/>
+                                          </p:stCondLst>
+                                        </p:cTn>
+                                        <p:tgtEl>
+                                          <p:spTgt spid="6"/>
+                                        </p:tgtEl>
+                                        <p:attrNameLst>
+                                          <p:attrName>xshear</p:attrName>
+                                        </p:attrNameLst>
+                                      </p:cBhvr>
+                                    </p:anim>
+                                    <p:animScale>
+                                      <p:cBhvr>
+                                        <p:cTn id="9" dur="200" decel="100000" autoRev="1" fill="hold">
+                                          <p:stCondLst>
+                                            <p:cond delay="600"/>
+                                          </p:stCondLst>
+                                        </p:cTn>
+                                        <p:tgtEl>
+                                          <p:spTgt spid="6"/>
+                                        </p:tgtEl>
+                                      </p:cBhvr>
+                                      <p:from x="100000" y="100000"/>
+                                      <p:to x="80000" y="100000"/>
+                                    </p:animScale>
+                                    <p:anim by="(#ppt_h/3+#ppt_w*0.1)" calcmode="lin" valueType="num">
+                                      <p:cBhvr additive="sum">
+                                        <p:cTn id="10" dur="200" decel="100000" autoRev="1" fill="hold">
+                                          <p:stCondLst>
+                                            <p:cond delay="600"/>
+                                          </p:stCondLst>
+                                        </p:cTn>
+                                        <p:tgtEl>
+                                          <p:spTgt spid="6"/>
+                                        </p:tgtEl>
+                                        <p:attrNameLst>
+                                          <p:attrName>ppt_x</p:attrName>
+                                        </p:attrNameLst>
+                                      </p:cBhvr>
+                                    </p:anim>
+                                  </p:childTnLst>
+                                </p:cTn>
+                              </p:par>
+                            </p:childTnLst>
+                          </p:cTn>
+                        </p:par>
+                      </p:childTnLst>
+                    </p:cTn>
+                  </p:par>
+                  <p:par>
+                    <p:cTn id="11" fill="hold">
+                      <p:stCondLst>
+                        <p:cond delay="indefinite"/>
+                      </p:stCondLst>
+                      <p:childTnLst>
+                        <p:par>
+                          <p:cTn id="12" fill="hold">
+                            <p:stCondLst>
+                              <p:cond delay="0"/>
+                            </p:stCondLst>
+                            <p:childTnLst>
+                              <p:par>
+                                <p:cTn id="13" presetID="34" presetClass="entr" presetSubtype="0" fill="hold" nodeType="clickEffect">
+                                  <p:stCondLst>
+                                    <p:cond delay="0"/>
+                                  </p:stCondLst>
+                                  <p:childTnLst>
+                                    <p:set>
+                                      <p:cBhvr>
+                                        <p:cTn id="14" dur="1" fill="hold">
+                                          <p:stCondLst>
+                                            <p:cond delay="0"/>
+                                          </p:stCondLst>
+                                        </p:cTn>
+                                        <p:tgtEl>
+                                          <p:spTgt spid="8"/>
+                                        </p:tgtEl>
+                                        <p:attrNameLst>
+                                          <p:attrName>style.visibility</p:attrName>
+                                        </p:attrNameLst>
+                                      </p:cBhvr>
+                                      <p:to>
+                                        <p:strVal val="visible"/>
+                                      </p:to>
+                                    </p:set>
+                                    <p:anim from="(-#ppt_w/2)" to="(#ppt_x)" calcmode="lin" valueType="num">
+                                      <p:cBhvr>
+                                        <p:cTn id="15" dur="600" fill="hold">
+                                          <p:stCondLst>
+                                            <p:cond delay="0"/>
+                                          </p:stCondLst>
+                                        </p:cTn>
+                                        <p:tgtEl>
+                                          <p:spTgt spid="8"/>
+                                        </p:tgtEl>
+                                        <p:attrNameLst>
+                                          <p:attrName>ppt_x</p:attrName>
+                                        </p:attrNameLst>
+                                      </p:cBhvr>
+                                    </p:anim>
+                                    <p:anim from="0" to="-1.0" calcmode="lin" valueType="num">
+                                      <p:cBhvr>
+                                        <p:cTn id="16" dur="200" decel="50000" autoRev="1" fill="hold">
+                                          <p:stCondLst>
+                                            <p:cond delay="600"/>
+                                          </p:stCondLst>
+                                        </p:cTn>
+                                        <p:tgtEl>
+                                          <p:spTgt spid="8"/>
+                                        </p:tgtEl>
+                                        <p:attrNameLst>
+                                          <p:attrName>xshear</p:attrName>
+                                        </p:attrNameLst>
+                                      </p:cBhvr>
+                                    </p:anim>
+                                    <p:animScale>
+                                      <p:cBhvr>
+                                        <p:cTn id="17" dur="200" decel="100000" autoRev="1" fill="hold">
+                                          <p:stCondLst>
+                                            <p:cond delay="600"/>
+                                          </p:stCondLst>
+                                        </p:cTn>
+                                        <p:tgtEl>
+                                          <p:spTgt spid="8"/>
+                                        </p:tgtEl>
+                                      </p:cBhvr>
+                                      <p:from x="100000" y="100000"/>
+                                      <p:to x="80000" y="100000"/>
+                                    </p:animScale>
+                                    <p:anim by="(#ppt_h/3+#ppt_w*0.1)" calcmode="lin" valueType="num">
+                                      <p:cBhvr additive="sum">
+                                        <p:cTn id="18" dur="200" decel="100000" autoRev="1" fill="hold">
+                                          <p:stCondLst>
+                                            <p:cond delay="600"/>
+                                          </p:stCondLst>
+                                        </p:cTn>
+                                        <p:tgtEl>
+                                          <p:spTgt spid="8"/>
+                                        </p:tgtEl>
+                                        <p:attrNameLst>
+                                          <p:attrName>ppt_x</p:attrName>
+                                        </p:attrNameLst>
+                                      </p:cBhvr>
+                                    </p:anim>
+                                  </p:childTnLst>
+                                </p:cTn>
+                              </p:par>
+                            </p:childTnLst>
+                          </p:cTn>
+                        </p:par>
+                      </p:childTnLst>
+                    </p:cTn>
+                  </p:par>
+                  <p:par>
+                    <p:cTn id="19" fill="hold">
+                      <p:stCondLst>
+                        <p:cond delay="indefinite"/>
+                      </p:stCondLst>
+                      <p:childTnLst>
+                        <p:par>
+                          <p:cTn id="20" fill="hold">
+                            <p:stCondLst>
+                              <p:cond delay="0"/>
+                            </p:stCondLst>
+                            <p:childTnLst>
+                              <p:par>
+                                <p:cTn id="21" presetID="34" presetClass="entr" presetSubtype="0" fill="hold" grpId="0" nodeType="clickEffect">
+                                  <p:stCondLst>
+                                    <p:cond delay="0"/>
+                                  </p:stCondLst>
+                                  <p:childTnLst>
+                                    <p:set>
+                                      <p:cBhvr>
+                                        <p:cTn id="22" dur="1" fill="hold">
+                                          <p:stCondLst>
+                                            <p:cond delay="0"/>
+                                          </p:stCondLst>
+                                        </p:cTn>
+                                        <p:tgtEl>
+                                          <p:spTgt spid="7"/>
+                                        </p:tgtEl>
+                                        <p:attrNameLst>
+                                          <p:attrName>style.visibility</p:attrName>
+                                        </p:attrNameLst>
+                                      </p:cBhvr>
+                                      <p:to>
+                                        <p:strVal val="visible"/>
+                                      </p:to>
+                                    </p:set>
+                                    <p:anim from="(-#ppt_w/2)" to="(#ppt_x)" calcmode="lin" valueType="num">
+                                      <p:cBhvr>
+                                        <p:cTn id="23" dur="600" fill="hold">
+                                          <p:stCondLst>
+                                            <p:cond delay="0"/>
+                                          </p:stCondLst>
+                                        </p:cTn>
+                                        <p:tgtEl>
+                                          <p:spTgt spid="7"/>
+                                        </p:tgtEl>
+                                        <p:attrNameLst>
+                                          <p:attrName>ppt_x</p:attrName>
+                                        </p:attrNameLst>
+                                      </p:cBhvr>
+                                    </p:anim>
+                                    <p:anim from="0" to="-1.0" calcmode="lin" valueType="num">
+                                      <p:cBhvr>
+                                        <p:cTn id="24" dur="200" decel="50000" autoRev="1" fill="hold">
+                                          <p:stCondLst>
+                                            <p:cond delay="600"/>
+                                          </p:stCondLst>
+                                        </p:cTn>
+                                        <p:tgtEl>
+                                          <p:spTgt spid="7"/>
+                                        </p:tgtEl>
+                                        <p:attrNameLst>
+                                          <p:attrName>xshear</p:attrName>
+                                        </p:attrNameLst>
+                                      </p:cBhvr>
+                                    </p:anim>
+                                    <p:animScale>
+                                      <p:cBhvr>
+                                        <p:cTn id="25" dur="200" decel="100000" autoRev="1" fill="hold">
+                                          <p:stCondLst>
+                                            <p:cond delay="600"/>
+                                          </p:stCondLst>
+                                        </p:cTn>
+                                        <p:tgtEl>
+                                          <p:spTgt spid="7"/>
+                                        </p:tgtEl>
+                                      </p:cBhvr>
+                                      <p:from x="100000" y="100000"/>
+                                      <p:to x="80000" y="100000"/>
+                                    </p:animScale>
+                                    <p:anim by="(#ppt_h/3+#ppt_w*0.1)" calcmode="lin" valueType="num">
+                                      <p:cBhvr additive="sum">
+                                        <p:cTn id="26" dur="200" decel="100000" autoRev="1" fill="hold">
+                                          <p:stCondLst>
+                                            <p:cond delay="600"/>
+                                          </p:stCondLst>
+                                        </p:cTn>
+                                        <p:tgtEl>
+                                          <p:spTgt spid="7"/>
+                                        </p:tgtEl>
+                                        <p:attrNameLst>
+                                          <p:attrName>ppt_x</p:attrName>
+                                        </p:attrNameLst>
+                                      </p:cBhvr>
+                                    </p:anim>
+                                  </p:childTnLst>
+                                </p:cTn>
+                              </p:par>
+                            </p:childTnLst>
+                          </p:cTn>
+                        </p:par>
+                      </p:childTnLst>
+                    </p:cTn>
+                  </p:par>
+                </p:childTnLst>
+              </p:cTn>
+              <p:prevCondLst>
+                <p:cond evt="onPrev" delay="0">
+                  <p:tgtEl>
+                    <p:sldTgt/>
+                  </p:tgtEl>
+                </p:cond>
+              </p:prevCondLst>
+              <p:nextCondLst>
+                <p:cond evt="onNext" delay="0">
+                  <p:tgtEl>
+                    <p:sldTgt/>
+                  </p:tgtEl>
+                </p:cond>
+              </p:nextCondLst>
+            </p:seq>
+          </p:childTnLst>
+        </p:cTn>
+      </p:par>
+    </p:tnLst>
+    <p:bldLst>
+      <p:bldP spid="7" grpId="0" animBg="1"/>
+    </p:bldLst>
+  </p:timing>
+</p:sld>
+</file>
+
+<file path=ppt/slides/slide12.xml><?xml version="1.0" encoding="utf-8"?>
+<p:sld xmlns:a="http://schemas.openxmlformats.org/drawingml/2006/main" xmlns:r="http://schemas.openxmlformats.org/officeDocument/2006/relationships" xmlns:p="http://schemas.openxmlformats.org/presentationml/2006/main">
+  <p:cSld>
+    <p:spTree>
+      <p:nvGrpSpPr>
+        <p:cNvPr id="1" name=""/>
+        <p:cNvGrpSpPr/>
+        <p:nvPr/>
+      </p:nvGrpSpPr>
+      <p:grpSpPr>
+        <a:xfrm>
+          <a:off x="0" y="0"/>
+          <a:ext cx="0" cy="0"/>
+          <a:chOff x="0" y="0"/>
+          <a:chExt cx="0" cy="0"/>
+        </a:xfrm>
+      </p:grpSpPr>
+      <p:sp>
+        <p:nvSpPr>
+          <p:cNvPr id="2" name="Title 1">
+            <a:extLst>
+              <a:ext uri="{FF2B5EF4-FFF2-40B4-BE49-F238E27FC236}">
+                <a16:creationId xmlns:a16="http://schemas.microsoft.com/office/drawing/2014/main" id="{7A1C4E30-2B55-4D71-9F02-113C77A0DC01}"/>
+              </a:ext>
+            </a:extLst>
+          </p:cNvPr>
+          <p:cNvSpPr>
+            <a:spLocks noGrp="1"/>
+          </p:cNvSpPr>
+          <p:nvPr>
+            <p:ph type="title"/>
+          </p:nvPr>
+        </p:nvSpPr>
+        <p:spPr/>
+        <p:txBody>
+          <a:bodyPr>
+            <a:noAutofit/>
+          </a:bodyPr>
+          <a:lstStyle/>
+          <a:p>
+            <a:r>
+              <a:rPr lang="en-US">
+                <a:solidFill>
+                  <a:srgbClr val="1F3864"/>
+                </a:solidFill>
+              </a:rPr>
+              <a:t>What the shape of the step plot tells you</a:t>
+            </a:r>
+          </a:p>
+        </p:txBody>
+      </p:sp>
+      <p:sp>
+        <p:nvSpPr>
+          <p:cNvPr id="4" name="Slide Number Placeholder 3">
+            <a:extLst>
+              <a:ext uri="{FF2B5EF4-FFF2-40B4-BE49-F238E27FC236}">
+                <a16:creationId xmlns:a16="http://schemas.microsoft.com/office/drawing/2014/main" id="{7A1C4E30-2B55-4D71-9F02-113C77A0DC03}"/>
+              </a:ext>
+            </a:extLst>
+          </p:cNvPr>
+          <p:cNvSpPr>
+            <a:spLocks noGrp="1"/>
+          </p:cNvSpPr>
+          <p:nvPr>
+            <p:ph type="sldNum" sz="quarter" idx="12"/>
+          </p:nvPr>
+        </p:nvSpPr>
+        <p:spPr/>
+        <p:txBody>
+          <a:bodyPr/>
+          <a:lstStyle/>
+          <a:p>
+            <a:fld id="{A80A81DD-F10A-4B1C-963A-0ABBB4865886}" type="slidenum">
+              <a:rPr lang="en-US" sz="1600" smtClean="0"/>
+              <a:t>12</a:t>
+            </a:fld>
+            <a:endParaRPr lang="en-US" sz="1600"/>
+          </a:p>
+        </p:txBody>
+      </p:sp>
+      <p:sp>
+        <p:nvSpPr>
+          <p:cNvPr id="9" name="Rule">
+            <a:extLst>
+              <a:ext uri="{FF2B5EF4-FFF2-40B4-BE49-F238E27FC236}">
+                <a16:creationId xmlns:a16="http://schemas.microsoft.com/office/drawing/2014/main" id="{7A1C4E30-2B55-4D71-9F02-113C77A0DC09}"/>
+              </a:ext>
+            </a:extLst>
+          </p:cNvPr>
+          <p:cNvSpPr txBox="1"/>
+          <p:nvPr/>
+        </p:nvSpPr>
+        <p:spPr>
+          <a:xfrm>
+            <a:off x="838200" y="1676400"/>
+            <a:ext cx="10515600" cy="430000"/>
+          </a:xfrm>
+          <a:prstGeom prst="rect">
+            <a:avLst/>
+          </a:prstGeom>
+          <a:noFill/>
+        </p:spPr>
+        <p:txBody>
+          <a:bodyPr vert="horz" wrap="square" rtlCol="0" anchor="ctr">
+            <a:noAutofit/>
+          </a:bodyPr>
+          <a:lstStyle/>
+          <a:p>
+            <a:pPr algn="ctr"/>
+            <a:r>
+              <a:rPr lang="en-US" sz="1800" b="1">
+                <a:solidFill>
+                  <a:srgbClr val="C00000"/>
+                </a:solidFill>
+              </a:rPr>
+              <a:t>A steep run means a lot of data there.    A flat run means a gap, or a tail.</a:t>
+            </a:r>
+          </a:p>
+        </p:txBody>
+      </p:sp>
+      <p:pic>
+        <p:nvPicPr>
+          <p:cNvPr id="6" name="Picture 5">
+            <a:extLst>
+              <a:ext uri="{FF2B5EF4-FFF2-40B4-BE49-F238E27FC236}">
+                <a16:creationId xmlns:a16="http://schemas.microsoft.com/office/drawing/2014/main" id="{7A1C4E30-2B55-4D71-9F02-113C77A0DC06}"/>
+              </a:ext>
+            </a:extLst>
+          </p:cNvPr>
+          <p:cNvPicPr>
+            <a:picLocks/>
+          </p:cNvPicPr>
+          <p:nvPr/>
+        </p:nvPicPr>
+        <p:blipFill>
+          <a:blip r:embed="rId2">
+            <a:extLst>
+              <a:ext uri="{28A0092B-C50C-407E-A947-70E740481C1C}">
+                <a14:useLocalDpi xmlns:a14="http://schemas.microsoft.com/office/drawing/2010/main" val="0"/>
+              </a:ext>
+            </a:extLst>
+          </a:blip>
+          <a:stretch>
+            <a:fillRect/>
+          </a:stretch>
+        </p:blipFill>
+        <p:spPr>
+          <a:xfrm>
+            <a:off x="1250545" y="2170000"/>
+            <a:ext cx="9690910" cy="4100000"/>
+          </a:xfrm>
+          <a:prstGeom prst="rect">
+            <a:avLst/>
+          </a:prstGeom>
+        </p:spPr>
+      </p:pic>
+      <p:sp>
+        <p:nvSpPr>
+          <p:cNvPr id="5" name="Title rule">
+            <a:extLst>
+              <a:ext uri="{FF2B5EF4-FFF2-40B4-BE49-F238E27FC236}">
+                <a16:creationId xmlns:a16="http://schemas.microsoft.com/office/drawing/2014/main" id="{7A1C4E30-2B55-4D71-9F02-113C77A0DC05}"/>
+              </a:ext>
+            </a:extLst>
+          </p:cNvPr>
+          <p:cNvSpPr/>
+          <p:nvPr/>
+        </p:nvSpPr>
+        <p:spPr>
+          <a:xfrm>
+            <a:off x="838200" y="1600200"/>
+            <a:ext cx="10515600" cy="38100"/>
+          </a:xfrm>
+          <a:prstGeom prst="rect">
+            <a:avLst/>
+          </a:prstGeom>
+          <a:solidFill>
+            <a:srgbClr val="4472C4"/>
+          </a:solidFill>
+          <a:ln w="12700" cap="flat" cmpd="sng" algn="ctr">
+            <a:noFill/>
+            <a:prstDash val="solid"/>
+            <a:miter lim="800000"/>
+          </a:ln>
+          <a:effectLst/>
+        </p:spPr>
+        <p:style>
+          <a:lnRef idx="2">
+            <a:schemeClr val="accent1">
+              <a:shade val="15000"/>
+            </a:schemeClr>
+          </a:lnRef>
+          <a:fillRef idx="1">
+            <a:schemeClr val="accent1"/>
+          </a:fillRef>
+          <a:effectRef idx="0">
+            <a:schemeClr val="accent1"/>
+          </a:effectRef>
+          <a:fontRef idx="minor">
+            <a:schemeClr val="lt1"/>
+          </a:fontRef>
+        </p:style>
+        <p:txBody>
+          <a:bodyPr rtlCol="0" anchor="ctr"/>
+          <a:lstStyle/>
+          <a:p>
+            <a:pPr algn="ctr"/>
+            <a:endParaRPr lang="en-US"/>
+          </a:p>
+        </p:txBody>
+      </p:sp>
+    </p:spTree>
+    <p:extLst>
+      <p:ext uri="{BB962C8B-B14F-4D97-AF65-F5344CB8AC3E}">
+        <p14:creationId xmlns:p14="http://schemas.microsoft.com/office/powerpoint/2010/main" val="1697533712"/>
+      </p:ext>
+    </p:extLst>
+  </p:cSld>
+  <p:clrMapOvr>
+    <a:masterClrMapping/>
+  </p:clrMapOvr>
+</p:sld>
+</file>
+
+<file path=ppt/slides/slide13.xml><?xml version="1.0" encoding="utf-8"?>
+<p:sld xmlns:a="http://schemas.openxmlformats.org/drawingml/2006/main" xmlns:r="http://schemas.openxmlformats.org/officeDocument/2006/relationships" xmlns:p="http://schemas.openxmlformats.org/presentationml/2006/main">
+  <p:cSld>
+    <p:spTree>
+      <p:nvGrpSpPr>
+        <p:cNvPr id="1" name=""/>
+        <p:cNvGrpSpPr/>
+        <p:nvPr/>
+      </p:nvGrpSpPr>
+      <p:grpSpPr>
+        <a:xfrm>
+          <a:off x="0" y="0"/>
+          <a:ext cx="0" cy="0"/>
+          <a:chOff x="0" y="0"/>
+          <a:chExt cx="0" cy="0"/>
+        </a:xfrm>
+      </p:grpSpPr>
+      <p:sp>
+        <p:nvSpPr>
           <p:cNvPr id="6" name="Body card">
             <a:extLst>
               <a:ext uri="{FF2B5EF4-FFF2-40B4-BE49-F238E27FC236}">
@@ -3442,7 +4831,7 @@
         <p:spPr>
           <a:xfrm>
             <a:off x="635000" y="1689100"/>
-            <a:ext cx="10922000" cy="2413000"/>
+            <a:ext cx="10922000" cy="2743200"/>
           </a:xfrm>
           <a:prstGeom prst="roundRect">
             <a:avLst>
@@ -3588,7 +4977,7 @@
             <a:pPr lvl="1"/>
             <a:r>
               <a:rPr lang="en-US" sz="1700"/>
-              <a:t>the histogram is still the only one of the three that shows peaks and gaps</a:t>
+              <a:t>the histogram shows peaks and gaps most directly - the step plot turns a gap into a flat shelf, and the boxplot loses it altogether</a:t>
             </a:r>
           </a:p>
         </p:txBody>
@@ -3703,7 +5092,7 @@
 </p:sld>
 </file>
 
-<file path=ppt/slides/slide11.xml><?xml version="1.0" encoding="utf-8"?>
+<file path=ppt/slides/slide14.xml><?xml version="1.0" encoding="utf-8"?>
 <p:sld xmlns:a="http://schemas.openxmlformats.org/drawingml/2006/main" xmlns:r="http://schemas.openxmlformats.org/officeDocument/2006/relationships" xmlns:p="http://schemas.openxmlformats.org/presentationml/2006/main">
   <p:cSld>
     <p:spTree>
@@ -4033,7 +5422,7 @@
 </p:sld>
 </file>
 
-<file path=ppt/slides/slide12.xml><?xml version="1.0" encoding="utf-8"?>
+<file path=ppt/slides/slide15.xml><?xml version="1.0" encoding="utf-8"?>
 <p:sld xmlns:a="http://schemas.openxmlformats.org/drawingml/2006/main" xmlns:r="http://schemas.openxmlformats.org/officeDocument/2006/relationships" xmlns:p="http://schemas.openxmlformats.org/presentationml/2006/main">
   <p:cSld>
     <p:spTree>
@@ -5211,6 +6600,255 @@
           <p:cNvPr id="2" name="Title 1">
             <a:extLst>
               <a:ext uri="{FF2B5EF4-FFF2-40B4-BE49-F238E27FC236}">
+                <a16:creationId xmlns:a16="http://schemas.microsoft.com/office/drawing/2014/main" id="{7A1C4E30-2B55-4D71-9F02-113C77A0D601}"/>
+              </a:ext>
+            </a:extLst>
+          </p:cNvPr>
+          <p:cNvSpPr>
+            <a:spLocks noGrp="1"/>
+          </p:cNvSpPr>
+          <p:nvPr>
+            <p:ph type="title"/>
+          </p:nvPr>
+        </p:nvSpPr>
+        <p:spPr/>
+        <p:txBody>
+          <a:bodyPr>
+            <a:noAutofit/>
+          </a:bodyPr>
+          <a:lstStyle/>
+          <a:p>
+            <a:r>
+              <a:rPr lang="en-US">
+                <a:solidFill>
+                  <a:srgbClr val="1F3864"/>
+                </a:solidFill>
+              </a:rPr>
+              <a:t>What a boxplot says about shape</a:t>
+            </a:r>
+          </a:p>
+        </p:txBody>
+      </p:sp>
+      <p:sp>
+        <p:nvSpPr>
+          <p:cNvPr id="3" name="Content Placeholder 2">
+            <a:extLst>
+              <a:ext uri="{FF2B5EF4-FFF2-40B4-BE49-F238E27FC236}">
+                <a16:creationId xmlns:a16="http://schemas.microsoft.com/office/drawing/2014/main" id="{7A1C4E30-2B55-4D71-9F02-113C77A0D602}"/>
+              </a:ext>
+            </a:extLst>
+          </p:cNvPr>
+          <p:cNvSpPr>
+            <a:spLocks noGrp="1"/>
+          </p:cNvSpPr>
+          <p:nvPr>
+            <p:ph idx="1"/>
+          </p:nvPr>
+        </p:nvSpPr>
+        <p:spPr>
+          <a:xfrm>
+            <a:off x="635000" y="1879600"/>
+            <a:ext cx="4572000" cy="3810000"/>
+          </a:xfrm>
+        </p:spPr>
+        <p:txBody>
+          <a:bodyPr>
+            <a:noAutofit/>
+          </a:bodyPr>
+          <a:lstStyle/>
+          <a:p>
+            <a:r>
+              <a:rPr lang="en-US" sz="1600"/>
+              <a:t>We ran out of time on this Wednesday. Four distributions, each with its boxplot drawn underneath the curve:</a:t>
+            </a:r>
+          </a:p>
+          <a:p>
+            <a:pPr lvl="1"/>
+            <a:r>
+              <a:rPr lang="en-US" sz="1600"/>
+              <a:t>symmetric - the median sits mid-box and the two whiskers are about equal</a:t>
+            </a:r>
+          </a:p>
+          <a:p>
+            <a:pPr lvl="1"/>
+            <a:r>
+              <a:rPr lang="en-US" sz="1600"/>
+              <a:t>skewed - the median is pushed toward the short whisker, and the long whisker points the way the tail runs</a:t>
+            </a:r>
+          </a:p>
+          <a:p>
+            <a:r>
+              <a:rPr lang="en-US" sz="1600"/>
+              <a:t>Now look at the bimodal panel. Its boxplot is the same picture as the symmetric one.</a:t>
+            </a:r>
+          </a:p>
+          <a:p>
+            <a:r>
+              <a:rPr lang="en-US" sz="1600" b="1">
+                <a:solidFill>
+                  <a:srgbClr val="C00000"/>
+                </a:solidFill>
+              </a:rPr>
+              <a:t>A boxplot cannot show peaks or gaps, so always read one beside a histogram.</a:t>
+            </a:r>
+          </a:p>
+        </p:txBody>
+      </p:sp>
+      <p:sp>
+        <p:nvSpPr>
+          <p:cNvPr id="4" name="Slide Number Placeholder 3">
+            <a:extLst>
+              <a:ext uri="{FF2B5EF4-FFF2-40B4-BE49-F238E27FC236}">
+                <a16:creationId xmlns:a16="http://schemas.microsoft.com/office/drawing/2014/main" id="{7A1C4E30-2B55-4D71-9F02-113C77A0D603}"/>
+              </a:ext>
+            </a:extLst>
+          </p:cNvPr>
+          <p:cNvSpPr>
+            <a:spLocks noGrp="1"/>
+          </p:cNvSpPr>
+          <p:nvPr>
+            <p:ph type="sldNum" sz="quarter" idx="12"/>
+          </p:nvPr>
+        </p:nvSpPr>
+        <p:spPr/>
+        <p:txBody>
+          <a:bodyPr/>
+          <a:lstStyle/>
+          <a:p>
+            <a:fld id="{A80A81DD-F10A-4B1C-963A-0ABBB4865886}" type="slidenum">
+              <a:rPr lang="en-US" sz="1600" smtClean="0"/>
+              <a:t>3</a:t>
+            </a:fld>
+            <a:endParaRPr lang="en-US" sz="1600"/>
+          </a:p>
+        </p:txBody>
+      </p:sp>
+      <p:pic>
+        <p:nvPicPr>
+          <p:cNvPr id="6" name="Picture 5">
+            <a:extLst>
+              <a:ext uri="{FF2B5EF4-FFF2-40B4-BE49-F238E27FC236}">
+                <a16:creationId xmlns:a16="http://schemas.microsoft.com/office/drawing/2014/main" id="{7A1C4E30-2B55-4D71-9F02-113C77A0D606}"/>
+              </a:ext>
+            </a:extLst>
+          </p:cNvPr>
+          <p:cNvPicPr>
+            <a:picLocks/>
+          </p:cNvPicPr>
+          <p:nvPr/>
+        </p:nvPicPr>
+        <p:blipFill>
+          <a:blip r:embed="rId2">
+            <a:extLst>
+              <a:ext uri="{28A0092B-C50C-407E-A947-70E740481C1C}">
+                <a14:useLocalDpi xmlns:a14="http://schemas.microsoft.com/office/drawing/2010/main" val="0"/>
+              </a:ext>
+            </a:extLst>
+          </a:blip>
+          <a:stretch>
+            <a:fillRect/>
+          </a:stretch>
+        </p:blipFill>
+        <p:spPr>
+          <a:xfrm>
+            <a:off x="5461000" y="1855000"/>
+            <a:ext cx="6223000" cy="3733800"/>
+          </a:xfrm>
+          <a:prstGeom prst="rect">
+            <a:avLst/>
+          </a:prstGeom>
+        </p:spPr>
+      </p:pic>
+      <p:sp>
+        <p:nvSpPr>
+          <p:cNvPr id="5" name="Title rule">
+            <a:extLst>
+              <a:ext uri="{FF2B5EF4-FFF2-40B4-BE49-F238E27FC236}">
+                <a16:creationId xmlns:a16="http://schemas.microsoft.com/office/drawing/2014/main" id="{7A1C4E30-2B55-4D71-9F02-113C77A0D605}"/>
+              </a:ext>
+            </a:extLst>
+          </p:cNvPr>
+          <p:cNvSpPr/>
+          <p:nvPr/>
+        </p:nvSpPr>
+        <p:spPr>
+          <a:xfrm>
+            <a:off x="838200" y="1600200"/>
+            <a:ext cx="10515600" cy="38100"/>
+          </a:xfrm>
+          <a:prstGeom prst="rect">
+            <a:avLst/>
+          </a:prstGeom>
+          <a:solidFill>
+            <a:srgbClr val="4472C4"/>
+          </a:solidFill>
+          <a:ln w="12700" cap="flat" cmpd="sng" algn="ctr">
+            <a:noFill/>
+            <a:prstDash val="solid"/>
+            <a:miter lim="800000"/>
+          </a:ln>
+          <a:effectLst/>
+        </p:spPr>
+        <p:style>
+          <a:lnRef idx="2">
+            <a:schemeClr val="accent1">
+              <a:shade val="15000"/>
+            </a:schemeClr>
+          </a:lnRef>
+          <a:fillRef idx="1">
+            <a:schemeClr val="accent1"/>
+          </a:fillRef>
+          <a:effectRef idx="0">
+            <a:schemeClr val="accent1"/>
+          </a:effectRef>
+          <a:fontRef idx="minor">
+            <a:schemeClr val="lt1"/>
+          </a:fontRef>
+        </p:style>
+        <p:txBody>
+          <a:bodyPr rtlCol="0" anchor="ctr"/>
+          <a:lstStyle/>
+          <a:p>
+            <a:pPr algn="ctr"/>
+            <a:endParaRPr lang="en-US"/>
+          </a:p>
+        </p:txBody>
+      </p:sp>
+    </p:spTree>
+    <p:extLst>
+      <p:ext uri="{BB962C8B-B14F-4D97-AF65-F5344CB8AC3E}">
+        <p14:creationId xmlns:p14="http://schemas.microsoft.com/office/powerpoint/2010/main" val="1697533701"/>
+      </p:ext>
+    </p:extLst>
+  </p:cSld>
+  <p:clrMapOvr>
+    <a:masterClrMapping/>
+  </p:clrMapOvr>
+</p:sld>
+</file>
+
+<file path=ppt/slides/slide4.xml><?xml version="1.0" encoding="utf-8"?>
+<p:sld xmlns:a="http://schemas.openxmlformats.org/drawingml/2006/main" xmlns:r="http://schemas.openxmlformats.org/officeDocument/2006/relationships" xmlns:p="http://schemas.openxmlformats.org/presentationml/2006/main">
+  <p:cSld>
+    <p:spTree>
+      <p:nvGrpSpPr>
+        <p:cNvPr id="1" name=""/>
+        <p:cNvGrpSpPr/>
+        <p:nvPr/>
+      </p:nvGrpSpPr>
+      <p:grpSpPr>
+        <a:xfrm>
+          <a:off x="0" y="0"/>
+          <a:ext cx="0" cy="0"/>
+          <a:chOff x="0" y="0"/>
+          <a:chExt cx="0" cy="0"/>
+        </a:xfrm>
+      </p:grpSpPr>
+      <p:sp>
+        <p:nvSpPr>
+          <p:cNvPr id="2" name="Title 1">
+            <a:extLst>
+              <a:ext uri="{FF2B5EF4-FFF2-40B4-BE49-F238E27FC236}">
                 <a16:creationId xmlns:a16="http://schemas.microsoft.com/office/drawing/2014/main" id="{2C8CB41F-6CB5-6FC3-1484-FBE224FA2C58}"/>
               </a:ext>
             </a:extLst>
@@ -5427,7 +7065,7 @@
 </p:sld>
 </file>
 
-<file path=ppt/slides/slide4.xml><?xml version="1.0" encoding="utf-8"?>
+<file path=ppt/slides/slide5.xml><?xml version="1.0" encoding="utf-8"?>
 <p:sld xmlns:a="http://schemas.openxmlformats.org/drawingml/2006/main" xmlns:r="http://schemas.openxmlformats.org/officeDocument/2006/relationships" xmlns:p="http://schemas.openxmlformats.org/presentationml/2006/main">
   <p:cSld>
     <p:spTree>
@@ -5716,7 +7354,7 @@
 </p:sld>
 </file>
 
-<file path=ppt/slides/slide5.xml><?xml version="1.0" encoding="utf-8"?>
+<file path=ppt/slides/slide6.xml><?xml version="1.0" encoding="utf-8"?>
 <p:sld xmlns:a="http://schemas.openxmlformats.org/drawingml/2006/main" xmlns:r="http://schemas.openxmlformats.org/officeDocument/2006/relationships" xmlns:p="http://schemas.openxmlformats.org/presentationml/2006/main">
   <p:cSld>
     <p:spTree>
@@ -5966,7 +7604,7 @@
 </p:sld>
 </file>
 
-<file path=ppt/slides/slide6.xml><?xml version="1.0" encoding="utf-8"?>
+<file path=ppt/slides/slide7.xml><?xml version="1.0" encoding="utf-8"?>
 <p:sld xmlns:a="http://schemas.openxmlformats.org/drawingml/2006/main" xmlns:r="http://schemas.openxmlformats.org/officeDocument/2006/relationships" xmlns:p="http://schemas.openxmlformats.org/presentationml/2006/main">
   <p:cSld>
     <p:spTree>
@@ -6243,7 +7881,7 @@
 </p:sld>
 </file>
 
-<file path=ppt/slides/slide7.xml><?xml version="1.0" encoding="utf-8"?>
+<file path=ppt/slides/slide8.xml><?xml version="1.0" encoding="utf-8"?>
 <p:sld xmlns:a="http://schemas.openxmlformats.org/drawingml/2006/main" xmlns:r="http://schemas.openxmlformats.org/officeDocument/2006/relationships" xmlns:p="http://schemas.openxmlformats.org/presentationml/2006/main">
   <p:cSld>
     <p:spTree>
@@ -6526,7 +8164,7 @@
 </p:sld>
 </file>
 
-<file path=ppt/slides/slide8.xml><?xml version="1.0" encoding="utf-8"?>
+<file path=ppt/slides/slide9.xml><?xml version="1.0" encoding="utf-8"?>
 <p:sld xmlns:a="http://schemas.openxmlformats.org/drawingml/2006/main" xmlns:r="http://schemas.openxmlformats.org/officeDocument/2006/relationships" xmlns:p="http://schemas.openxmlformats.org/presentationml/2006/main">
   <p:cSld>
     <p:spTree>
@@ -7026,426 +8664,6 @@
     <p:bldLst>
       <p:bldP spid="7" grpId="0" animBg="1"/>
     </p:bldLst>
-  </p:timing>
-</p:sld>
-</file>
-
-<file path=ppt/slides/slide9.xml><?xml version="1.0" encoding="utf-8"?>
-<p:sld xmlns:a="http://schemas.openxmlformats.org/drawingml/2006/main" xmlns:r="http://schemas.openxmlformats.org/officeDocument/2006/relationships" xmlns:p="http://schemas.openxmlformats.org/presentationml/2006/main">
-  <p:cSld>
-    <p:spTree>
-      <p:nvGrpSpPr>
-        <p:cNvPr id="1" name=""/>
-        <p:cNvGrpSpPr/>
-        <p:nvPr/>
-      </p:nvGrpSpPr>
-      <p:grpSpPr>
-        <a:xfrm>
-          <a:off x="0" y="0"/>
-          <a:ext cx="0" cy="0"/>
-          <a:chOff x="0" y="0"/>
-          <a:chExt cx="0" cy="0"/>
-        </a:xfrm>
-      </p:grpSpPr>
-      <p:sp>
-        <p:nvSpPr>
-          <p:cNvPr id="2" name="Title 1">
-            <a:extLst>
-              <a:ext uri="{FF2B5EF4-FFF2-40B4-BE49-F238E27FC236}">
-                <a16:creationId xmlns:a16="http://schemas.microsoft.com/office/drawing/2014/main" id="{1D5CCA51-4EC5-8EF4-B4E0-B26D66EC7E0F}"/>
-              </a:ext>
-            </a:extLst>
-          </p:cNvPr>
-          <p:cNvSpPr>
-            <a:spLocks noGrp="1"/>
-          </p:cNvSpPr>
-          <p:nvPr>
-            <p:ph type="title"/>
-          </p:nvPr>
-        </p:nvSpPr>
-        <p:spPr/>
-        <p:txBody>
-          <a:bodyPr>
-            <a:noAutofit/>
-          </a:bodyPr>
-          <a:lstStyle/>
-          <a:p>
-            <a:r>
-              <a:rPr lang="en-US">
-                <a:solidFill>
-                  <a:srgbClr val="1F3864"/>
-                </a:solidFill>
-              </a:rPr>
-              <a:t>Practice: quartiles from a cumulative distribution</a:t>
-            </a:r>
-          </a:p>
-        </p:txBody>
-      </p:sp>
-      <p:sp>
-        <p:nvSpPr>
-          <p:cNvPr id="3" name="Content Placeholder 2">
-            <a:extLst>
-              <a:ext uri="{FF2B5EF4-FFF2-40B4-BE49-F238E27FC236}">
-                <a16:creationId xmlns:a16="http://schemas.microsoft.com/office/drawing/2014/main" id="{BBC1650B-D9BA-A561-42E5-30C77F9CD288}"/>
-              </a:ext>
-            </a:extLst>
-          </p:cNvPr>
-          <p:cNvSpPr>
-            <a:spLocks noGrp="1"/>
-          </p:cNvSpPr>
-          <p:nvPr>
-            <p:ph idx="1"/>
-          </p:nvPr>
-        </p:nvSpPr>
-        <p:spPr>
-          <a:xfrm>
-            <a:off x="635000" y="1879600"/>
-            <a:ext cx="4572000" cy="3810000"/>
-          </a:xfrm>
-        </p:spPr>
-        <p:txBody>
-          <a:bodyPr>
-            <a:noAutofit/>
-          </a:bodyPr>
-          <a:lstStyle/>
-          <a:p>
-            <a:r>
-              <a:rPr lang="en-US" sz="1600"/>
-              <a:t>This is the cumulative distribution of the 15 exam scores from Wednesday</a:t>
-            </a:r>
-          </a:p>
-          <a:p>
-            <a:r>
-              <a:rPr lang="en-US" sz="1600"/>
-              <a:t>Read Q1, Q2 and Q3 off the plot</a:t>
-            </a:r>
-          </a:p>
-          <a:p>
-            <a:r>
-              <a:rPr lang="en-US" sz="1600"/>
-              <a:t>n = 15 is odd this time. Does the midpoint rule come into it?</a:t>
-            </a:r>
-          </a:p>
-          <a:p>
-            <a:r>
-              <a:rPr lang="en-US" sz="1600"/>
-              <a:t>Then check your answers against the ones you got by halving the ordered data</a:t>
-            </a:r>
-          </a:p>
-        </p:txBody>
-      </p:sp>
-      <p:sp>
-        <p:nvSpPr>
-          <p:cNvPr id="4" name="Slide Number Placeholder 3">
-            <a:extLst>
-              <a:ext uri="{FF2B5EF4-FFF2-40B4-BE49-F238E27FC236}">
-                <a16:creationId xmlns:a16="http://schemas.microsoft.com/office/drawing/2014/main" id="{2F455BBE-5DF2-C42B-0548-00212CED9AAC}"/>
-              </a:ext>
-            </a:extLst>
-          </p:cNvPr>
-          <p:cNvSpPr>
-            <a:spLocks noGrp="1"/>
-          </p:cNvSpPr>
-          <p:nvPr>
-            <p:ph type="sldNum" sz="quarter" idx="12"/>
-          </p:nvPr>
-        </p:nvSpPr>
-        <p:spPr/>
-        <p:txBody>
-          <a:bodyPr/>
-          <a:lstStyle/>
-          <a:p>
-            <a:fld id="{A80A81DD-F10A-4B1C-963A-0ABBB4865886}" type="slidenum">
-              <a:rPr lang="en-US" sz="1600" smtClean="0"/>
-              <a:t>9</a:t>
-            </a:fld>
-            <a:endParaRPr lang="en-US" sz="1600"/>
-          </a:p>
-        </p:txBody>
-      </p:sp>
-      <p:pic>
-        <p:nvPicPr>
-          <p:cNvPr id="6" name="Picture 5">
-            <a:extLst>
-              <a:ext uri="{FF2B5EF4-FFF2-40B4-BE49-F238E27FC236}">
-                <a16:creationId xmlns:a16="http://schemas.microsoft.com/office/drawing/2014/main" id="{6CE810EC-64F0-6117-7B45-29959CEE35ED}"/>
-              </a:ext>
-            </a:extLst>
-          </p:cNvPr>
-          <p:cNvPicPr>
-            <a:picLocks/>
-          </p:cNvPicPr>
-          <p:nvPr/>
-        </p:nvPicPr>
-        <p:blipFill>
-          <a:blip r:embed="rId2">
-            <a:extLst>
-              <a:ext uri="{28A0092B-C50C-407E-A947-70E740481C1C}">
-                <a14:useLocalDpi xmlns:a14="http://schemas.microsoft.com/office/drawing/2010/main" val="0"/>
-              </a:ext>
-            </a:extLst>
-          </a:blip>
-          <a:stretch>
-            <a:fillRect/>
-          </a:stretch>
-        </p:blipFill>
-        <p:spPr>
-          <a:xfrm>
-            <a:off x="5461000" y="1778000"/>
-            <a:ext cx="6223000" cy="3889375"/>
-          </a:xfrm>
-          <a:prstGeom prst="rect">
-            <a:avLst/>
-          </a:prstGeom>
-        </p:spPr>
-      </p:pic>
-      <p:pic>
-        <p:nvPicPr>
-          <p:cNvPr id="8" name="Picture 7">
-            <a:extLst>
-              <a:ext uri="{FF2B5EF4-FFF2-40B4-BE49-F238E27FC236}">
-                <a16:creationId xmlns:a16="http://schemas.microsoft.com/office/drawing/2014/main" id="{F415B7CE-4BC1-DE83-57CC-5B1CF9E301AC}"/>
-              </a:ext>
-            </a:extLst>
-          </p:cNvPr>
-          <p:cNvPicPr>
-            <a:picLocks/>
-          </p:cNvPicPr>
-          <p:nvPr/>
-        </p:nvPicPr>
-        <p:blipFill>
-          <a:blip r:embed="rId3">
-            <a:extLst>
-              <a:ext uri="{28A0092B-C50C-407E-A947-70E740481C1C}">
-                <a14:useLocalDpi xmlns:a14="http://schemas.microsoft.com/office/drawing/2010/main" val="0"/>
-              </a:ext>
-            </a:extLst>
-          </a:blip>
-          <a:stretch>
-            <a:fillRect/>
-          </a:stretch>
-        </p:blipFill>
-        <p:spPr>
-          <a:xfrm>
-            <a:off x="5461000" y="1778000"/>
-            <a:ext cx="6223000" cy="3889375"/>
-          </a:xfrm>
-          <a:prstGeom prst="rect">
-            <a:avLst/>
-          </a:prstGeom>
-        </p:spPr>
-      </p:pic>
-      <p:sp>
-        <p:nvSpPr>
-          <p:cNvPr id="5" name="Title rule">
-            <a:extLst>
-              <a:ext uri="{FF2B5EF4-FFF2-40B4-BE49-F238E27FC236}">
-                <a16:creationId xmlns:a16="http://schemas.microsoft.com/office/drawing/2014/main" id="{520B32A0-1D02-B6D6-723F-16EFF1484E1E}"/>
-              </a:ext>
-            </a:extLst>
-          </p:cNvPr>
-          <p:cNvSpPr/>
-          <p:nvPr/>
-        </p:nvSpPr>
-        <p:spPr>
-          <a:xfrm>
-            <a:off x="838200" y="1600200"/>
-            <a:ext cx="10515600" cy="38100"/>
-          </a:xfrm>
-          <a:prstGeom prst="rect">
-            <a:avLst/>
-          </a:prstGeom>
-          <a:solidFill>
-            <a:srgbClr val="4472C4"/>
-          </a:solidFill>
-          <a:ln w="12700" cap="flat" cmpd="sng" algn="ctr">
-            <a:noFill/>
-            <a:prstDash val="solid"/>
-            <a:miter lim="800000"/>
-          </a:ln>
-          <a:effectLst/>
-          <a:extLst>
-            <a:ext uri="{91240B29-F687-4F45-9708-019B960494DF}">
-              <a14:hiddenLine xmlns:a14="http://schemas.microsoft.com/office/drawing/2010/main" w="12700" cap="flat" cmpd="sng" algn="ctr">
-                <a:solidFill>
-                  <a:schemeClr val="accent1">
-                    <a:shade val="15000"/>
-                  </a:schemeClr>
-                </a:solidFill>
-                <a:prstDash val="solid"/>
-                <a:miter lim="800000"/>
-              </a14:hiddenLine>
-            </a:ext>
-          </a:extLst>
-        </p:spPr>
-        <p:style>
-          <a:lnRef idx="2">
-            <a:schemeClr val="accent1">
-              <a:shade val="15000"/>
-            </a:schemeClr>
-          </a:lnRef>
-          <a:fillRef idx="1">
-            <a:schemeClr val="accent1"/>
-          </a:fillRef>
-          <a:effectRef idx="0">
-            <a:schemeClr val="accent1"/>
-          </a:effectRef>
-          <a:fontRef idx="minor">
-            <a:schemeClr val="lt1"/>
-          </a:fontRef>
-        </p:style>
-        <p:txBody>
-          <a:bodyPr rtlCol="0" anchor="ctr"/>
-          <a:lstStyle/>
-          <a:p>
-            <a:pPr algn="ctr"/>
-            <a:endParaRPr lang="en-US"/>
-          </a:p>
-        </p:txBody>
-      </p:sp>
-    </p:spTree>
-    <p:extLst>
-      <p:ext uri="{BB962C8B-B14F-4D97-AF65-F5344CB8AC3E}">
-        <p14:creationId xmlns:p14="http://schemas.microsoft.com/office/powerpoint/2010/main" val="1010812355"/>
-      </p:ext>
-    </p:extLst>
-  </p:cSld>
-  <p:clrMapOvr>
-    <a:masterClrMapping/>
-  </p:clrMapOvr>
-  <p:timing>
-    <p:tnLst>
-      <p:par>
-        <p:cTn id="1" dur="indefinite" restart="never" nodeType="tmRoot">
-          <p:childTnLst>
-            <p:seq concurrent="1" nextAc="seek">
-              <p:cTn id="2" dur="indefinite" nodeType="mainSeq">
-                <p:childTnLst>
-                  <p:par>
-                    <p:cTn id="3" fill="hold">
-                      <p:stCondLst>
-                        <p:cond delay="indefinite"/>
-                      </p:stCondLst>
-                      <p:childTnLst>
-                        <p:par>
-                          <p:cTn id="4" fill="hold">
-                            <p:stCondLst>
-                              <p:cond delay="0"/>
-                            </p:stCondLst>
-                            <p:childTnLst>
-                              <p:par>
-                                <p:cTn id="5" presetID="34" presetClass="entr" presetSubtype="0" fill="hold" nodeType="clickEffect">
-                                  <p:stCondLst>
-                                    <p:cond delay="0"/>
-                                  </p:stCondLst>
-                                  <p:childTnLst>
-                                    <p:set>
-                                      <p:cBhvr>
-                                        <p:cTn id="6" dur="1" fill="hold">
-                                          <p:stCondLst>
-                                            <p:cond delay="0"/>
-                                          </p:stCondLst>
-                                        </p:cTn>
-                                        <p:tgtEl>
-                                          <p:spTgt spid="8"/>
-                                        </p:tgtEl>
-                                        <p:attrNameLst>
-                                          <p:attrName>style.visibility</p:attrName>
-                                        </p:attrNameLst>
-                                      </p:cBhvr>
-                                      <p:to>
-                                        <p:strVal val="visible"/>
-                                      </p:to>
-                                    </p:set>
-                                    <p:anim from="(-#ppt_w/2)" to="(#ppt_x)" calcmode="lin" valueType="num">
-                                      <p:cBhvr>
-                                        <p:cTn id="7" dur="600" fill="hold">
-                                          <p:stCondLst>
-                                            <p:cond delay="0"/>
-                                          </p:stCondLst>
-                                        </p:cTn>
-                                        <p:tgtEl>
-                                          <p:spTgt spid="8"/>
-                                        </p:tgtEl>
-                                        <p:attrNameLst>
-                                          <p:attrName>ppt_x</p:attrName>
-                                        </p:attrNameLst>
-                                      </p:cBhvr>
-                                    </p:anim>
-                                    <p:anim from="0" to="-1.0" calcmode="lin" valueType="num">
-                                      <p:cBhvr>
-                                        <p:cTn id="8" dur="200" decel="50000" autoRev="1" fill="hold">
-                                          <p:stCondLst>
-                                            <p:cond delay="600"/>
-                                          </p:stCondLst>
-                                        </p:cTn>
-                                        <p:tgtEl>
-                                          <p:spTgt spid="8"/>
-                                        </p:tgtEl>
-                                        <p:attrNameLst>
-                                          <p:attrName>xshear</p:attrName>
-                                        </p:attrNameLst>
-                                      </p:cBhvr>
-                                    </p:anim>
-                                    <p:animScale>
-                                      <p:cBhvr>
-                                        <p:cTn id="9" dur="200" decel="100000" autoRev="1" fill="hold">
-                                          <p:stCondLst>
-                                            <p:cond delay="600"/>
-                                          </p:stCondLst>
-                                        </p:cTn>
-                                        <p:tgtEl>
-                                          <p:spTgt spid="8"/>
-                                        </p:tgtEl>
-                                      </p:cBhvr>
-                                      <p:from x="100000" y="100000"/>
-                                      <p:to x="80000" y="100000"/>
-                                    </p:animScale>
-                                    <p:anim by="(#ppt_h/3+#ppt_w*0.1)" calcmode="lin" valueType="num">
-                                      <p:cBhvr additive="sum">
-                                        <p:cTn id="10" dur="200" decel="100000" autoRev="1" fill="hold">
-                                          <p:stCondLst>
-                                            <p:cond delay="600"/>
-                                          </p:stCondLst>
-                                        </p:cTn>
-                                        <p:tgtEl>
-                                          <p:spTgt spid="8"/>
-                                        </p:tgtEl>
-                                        <p:attrNameLst>
-                                          <p:attrName>ppt_x</p:attrName>
-                                        </p:attrNameLst>
-                                      </p:cBhvr>
-                                    </p:anim>
-                                  </p:childTnLst>
-                                </p:cTn>
-                              </p:par>
-                            </p:childTnLst>
-                          </p:cTn>
-                        </p:par>
-                      </p:childTnLst>
-                    </p:cTn>
-                  </p:par>
-                </p:childTnLst>
-              </p:cTn>
-              <p:prevCondLst>
-                <p:cond evt="onPrev" delay="0">
-                  <p:tgtEl>
-                    <p:sldTgt/>
-                  </p:tgtEl>
-                </p:cond>
-              </p:prevCondLst>
-              <p:nextCondLst>
-                <p:cond evt="onNext" delay="0">
-                  <p:tgtEl>
-                    <p:sldTgt/>
-                  </p:tgtEl>
-                </p:cond>
-              </p:nextCondLst>
-            </p:seq>
-          </p:childTnLst>
-        </p:cTn>
-      </p:par>
-    </p:tnLst>
   </p:timing>
 </p:sld>
 </file>

</xml_diff>

<commit_message>
Publish Week 4 lecture 8 materials
Enable Week 4 in the site navigation and slides index, add the new Lecture 8 slide deck, and replace the old Week 4 notes with a full sampling/experimental design write-up plus generated figures and supporting assets. The update also moves the normal distribution and z-score material into Week 5, removes duplicated outdated survey/design content from later notes, and aligns the course schedule, reading list, and Exam 2 study guide with the revised pacing.
</commit_message>
<xml_diff>
--- a/docs/lecture_slides/Week 3/Week3_Lecture7_Slides_9_11_2026.pptx
+++ b/docs/lecture_slides/Week 3/Week3_Lecture7_Slides_9_11_2026.pptx
@@ -17,9 +17,6 @@
     <p:sldId id="265" r:id="rId11"/>
     <p:sldId id="266" r:id="rId12"/>
     <p:sldId id="267" r:id="rId13"/>
-    <p:sldId id="268" r:id="rId14"/>
-    <p:sldId id="269" r:id="rId15"/>
-    <p:sldId id="270" r:id="rId16"/>
   </p:sldIdLst>
   <p:sldSz cx="12192000" cy="6858000"/>
   <p:notesSz cx="6858000" cy="9144000"/>
@@ -273,7 +270,7 @@
           <a:p>
             <a:fld id="{06882561-BD16-4A95-ACA1-5204E478F2FE}" type="datetimeFigureOut">
               <a:rPr lang="en-US" smtClean="0"/>
-              <a:t>9/9/2026</a:t>
+              <a:t>9/11/2026</a:t>
             </a:fld>
             <a:endParaRPr lang="en-US"/>
           </a:p>
@@ -471,7 +468,7 @@
           <a:p>
             <a:fld id="{06882561-BD16-4A95-ACA1-5204E478F2FE}" type="datetimeFigureOut">
               <a:rPr lang="en-US" smtClean="0"/>
-              <a:t>9/9/2026</a:t>
+              <a:t>9/11/2026</a:t>
             </a:fld>
             <a:endParaRPr lang="en-US"/>
           </a:p>
@@ -679,7 +676,7 @@
           <a:p>
             <a:fld id="{06882561-BD16-4A95-ACA1-5204E478F2FE}" type="datetimeFigureOut">
               <a:rPr lang="en-US" smtClean="0"/>
-              <a:t>9/9/2026</a:t>
+              <a:t>9/11/2026</a:t>
             </a:fld>
             <a:endParaRPr lang="en-US"/>
           </a:p>
@@ -877,7 +874,7 @@
           <a:p>
             <a:fld id="{06882561-BD16-4A95-ACA1-5204E478F2FE}" type="datetimeFigureOut">
               <a:rPr lang="en-US" smtClean="0"/>
-              <a:t>9/9/2026</a:t>
+              <a:t>9/11/2026</a:t>
             </a:fld>
             <a:endParaRPr lang="en-US"/>
           </a:p>
@@ -1152,7 +1149,7 @@
           <a:p>
             <a:fld id="{06882561-BD16-4A95-ACA1-5204E478F2FE}" type="datetimeFigureOut">
               <a:rPr lang="en-US" smtClean="0"/>
-              <a:t>9/9/2026</a:t>
+              <a:t>9/11/2026</a:t>
             </a:fld>
             <a:endParaRPr lang="en-US"/>
           </a:p>
@@ -1417,7 +1414,7 @@
           <a:p>
             <a:fld id="{06882561-BD16-4A95-ACA1-5204E478F2FE}" type="datetimeFigureOut">
               <a:rPr lang="en-US" smtClean="0"/>
-              <a:t>9/9/2026</a:t>
+              <a:t>9/11/2026</a:t>
             </a:fld>
             <a:endParaRPr lang="en-US"/>
           </a:p>
@@ -1829,7 +1826,7 @@
           <a:p>
             <a:fld id="{06882561-BD16-4A95-ACA1-5204E478F2FE}" type="datetimeFigureOut">
               <a:rPr lang="en-US" smtClean="0"/>
-              <a:t>9/9/2026</a:t>
+              <a:t>9/11/2026</a:t>
             </a:fld>
             <a:endParaRPr lang="en-US"/>
           </a:p>
@@ -1970,7 +1967,7 @@
           <a:p>
             <a:fld id="{06882561-BD16-4A95-ACA1-5204E478F2FE}" type="datetimeFigureOut">
               <a:rPr lang="en-US" smtClean="0"/>
-              <a:t>9/9/2026</a:t>
+              <a:t>9/11/2026</a:t>
             </a:fld>
             <a:endParaRPr lang="en-US"/>
           </a:p>
@@ -2083,7 +2080,7 @@
           <a:p>
             <a:fld id="{06882561-BD16-4A95-ACA1-5204E478F2FE}" type="datetimeFigureOut">
               <a:rPr lang="en-US" smtClean="0"/>
-              <a:t>9/9/2026</a:t>
+              <a:t>9/11/2026</a:t>
             </a:fld>
             <a:endParaRPr lang="en-US"/>
           </a:p>
@@ -2394,7 +2391,7 @@
           <a:p>
             <a:fld id="{06882561-BD16-4A95-ACA1-5204E478F2FE}" type="datetimeFigureOut">
               <a:rPr lang="en-US" smtClean="0"/>
-              <a:t>9/9/2026</a:t>
+              <a:t>9/11/2026</a:t>
             </a:fld>
             <a:endParaRPr lang="en-US"/>
           </a:p>
@@ -2682,7 +2679,7 @@
           <a:p>
             <a:fld id="{06882561-BD16-4A95-ACA1-5204E478F2FE}" type="datetimeFigureOut">
               <a:rPr lang="en-US" smtClean="0"/>
-              <a:t>9/9/2026</a:t>
+              <a:t>9/11/2026</a:t>
             </a:fld>
             <a:endParaRPr lang="en-US"/>
           </a:p>
@@ -2923,7 +2920,7 @@
           <a:p>
             <a:fld id="{06882561-BD16-4A95-ACA1-5204E478F2FE}" type="datetimeFigureOut">
               <a:rPr lang="en-US" smtClean="0"/>
-              <a:t>9/9/2026</a:t>
+              <a:t>9/11/2026</a:t>
             </a:fld>
             <a:endParaRPr lang="en-US"/>
           </a:p>
@@ -4790,934 +4787,6 @@
     <p:extLst>
       <p:ext uri="{BB962C8B-B14F-4D97-AF65-F5344CB8AC3E}">
         <p14:creationId xmlns:p14="http://schemas.microsoft.com/office/powerpoint/2010/main" val="1697533712"/>
-      </p:ext>
-    </p:extLst>
-  </p:cSld>
-  <p:clrMapOvr>
-    <a:masterClrMapping/>
-  </p:clrMapOvr>
-</p:sld>
-</file>
-
-<file path=ppt/slides/slide13.xml><?xml version="1.0" encoding="utf-8"?>
-<p:sld xmlns:a="http://schemas.openxmlformats.org/drawingml/2006/main" xmlns:r="http://schemas.openxmlformats.org/officeDocument/2006/relationships" xmlns:p="http://schemas.openxmlformats.org/presentationml/2006/main">
-  <p:cSld>
-    <p:spTree>
-      <p:nvGrpSpPr>
-        <p:cNvPr id="1" name=""/>
-        <p:cNvGrpSpPr/>
-        <p:nvPr/>
-      </p:nvGrpSpPr>
-      <p:grpSpPr>
-        <a:xfrm>
-          <a:off x="0" y="0"/>
-          <a:ext cx="0" cy="0"/>
-          <a:chOff x="0" y="0"/>
-          <a:chExt cx="0" cy="0"/>
-        </a:xfrm>
-      </p:grpSpPr>
-      <p:sp>
-        <p:nvSpPr>
-          <p:cNvPr id="6" name="Body card">
-            <a:extLst>
-              <a:ext uri="{FF2B5EF4-FFF2-40B4-BE49-F238E27FC236}">
-                <a16:creationId xmlns:a16="http://schemas.microsoft.com/office/drawing/2014/main" id="{24052BCE-7E92-E165-5A67-8C5258BABF4B}"/>
-              </a:ext>
-            </a:extLst>
-          </p:cNvPr>
-          <p:cNvSpPr/>
-          <p:nvPr/>
-        </p:nvSpPr>
-        <p:spPr>
-          <a:xfrm>
-            <a:off x="635000" y="1689100"/>
-            <a:ext cx="10922000" cy="2743200"/>
-          </a:xfrm>
-          <a:prstGeom prst="roundRect">
-            <a:avLst>
-              <a:gd name="adj" fmla="val 3000"/>
-            </a:avLst>
-          </a:prstGeom>
-          <a:solidFill>
-            <a:srgbClr val="F2F6FC"/>
-          </a:solidFill>
-          <a:ln w="19050">
-            <a:solidFill>
-              <a:srgbClr val="4472C4"/>
-            </a:solidFill>
-          </a:ln>
-        </p:spPr>
-        <p:style>
-          <a:lnRef idx="2">
-            <a:schemeClr val="accent1">
-              <a:shade val="15000"/>
-            </a:schemeClr>
-          </a:lnRef>
-          <a:fillRef idx="1">
-            <a:schemeClr val="accent1"/>
-          </a:fillRef>
-          <a:effectRef idx="0">
-            <a:schemeClr val="accent1"/>
-          </a:effectRef>
-          <a:fontRef idx="minor">
-            <a:schemeClr val="lt1"/>
-          </a:fontRef>
-        </p:style>
-        <p:txBody>
-          <a:bodyPr rtlCol="0" anchor="ctr"/>
-          <a:lstStyle/>
-          <a:p>
-            <a:pPr algn="ctr"/>
-            <a:endParaRPr lang="en-US"/>
-          </a:p>
-        </p:txBody>
-      </p:sp>
-      <p:sp>
-        <p:nvSpPr>
-          <p:cNvPr id="2" name="Title 1">
-            <a:extLst>
-              <a:ext uri="{FF2B5EF4-FFF2-40B4-BE49-F238E27FC236}">
-                <a16:creationId xmlns:a16="http://schemas.microsoft.com/office/drawing/2014/main" id="{AEA3F97C-CD01-FE3D-43C8-10B2BF6D76C6}"/>
-              </a:ext>
-            </a:extLst>
-          </p:cNvPr>
-          <p:cNvSpPr>
-            <a:spLocks noGrp="1"/>
-          </p:cNvSpPr>
-          <p:nvPr>
-            <p:ph type="title"/>
-          </p:nvPr>
-        </p:nvSpPr>
-        <p:spPr/>
-        <p:txBody>
-          <a:bodyPr>
-            <a:noAutofit/>
-          </a:bodyPr>
-          <a:lstStyle/>
-          <a:p>
-            <a:r>
-              <a:rPr lang="en-US">
-                <a:solidFill>
-                  <a:srgbClr val="1F3864"/>
-                </a:solidFill>
-              </a:rPr>
-              <a:t>Two pictures of the same five numbers</a:t>
-            </a:r>
-          </a:p>
-        </p:txBody>
-      </p:sp>
-      <p:sp>
-        <p:nvSpPr>
-          <p:cNvPr id="3" name="Content Placeholder 2">
-            <a:extLst>
-              <a:ext uri="{FF2B5EF4-FFF2-40B4-BE49-F238E27FC236}">
-                <a16:creationId xmlns:a16="http://schemas.microsoft.com/office/drawing/2014/main" id="{A29B628F-387A-3F1D-B40B-3578F8841427}"/>
-              </a:ext>
-            </a:extLst>
-          </p:cNvPr>
-          <p:cNvSpPr>
-            <a:spLocks noGrp="1"/>
-          </p:cNvSpPr>
-          <p:nvPr>
-            <p:ph idx="1"/>
-          </p:nvPr>
-        </p:nvSpPr>
-        <p:spPr>
-          <a:xfrm>
-            <a:off x="762000" y="1841500"/>
-            <a:ext cx="10668000" cy="4064000"/>
-          </a:xfrm>
-        </p:spPr>
-        <p:txBody>
-          <a:bodyPr>
-            <a:noAutofit/>
-          </a:bodyPr>
-          <a:lstStyle/>
-          <a:p>
-            <a:r>
-              <a:rPr lang="en-US" sz="1700"/>
-              <a:t>The step plot and the boxplot are not competing summaries - the boxplot is five readings off the step plot</a:t>
-            </a:r>
-          </a:p>
-          <a:p>
-            <a:pPr lvl="1"/>
-            <a:r>
-              <a:rPr lang="en-US" sz="1700"/>
-              <a:t>the minimum is where the curve leaves 0, the maximum is where it reaches 1</a:t>
-            </a:r>
-          </a:p>
-          <a:p>
-            <a:pPr lvl="1"/>
-            <a:r>
-              <a:rPr lang="en-US" sz="1700"/>
-              <a:t>Q1, Q2 and Q3 are the readings at 0.25, 0.50 and 0.75</a:t>
-            </a:r>
-          </a:p>
-          <a:p>
-            <a:r>
-              <a:rPr lang="en-US" sz="1700"/>
-              <a:t>What each one is good for:</a:t>
-            </a:r>
-          </a:p>
-          <a:p>
-            <a:pPr lvl="1"/>
-            <a:r>
-              <a:rPr lang="en-US" sz="1700"/>
-              <a:t>the step plot gives you ANY percentile, not just the quartiles</a:t>
-            </a:r>
-          </a:p>
-          <a:p>
-            <a:pPr lvl="1"/>
-            <a:r>
-              <a:rPr lang="en-US" sz="1700"/>
-              <a:t>the boxplot is far easier to compare across groups, and it flags outliers</a:t>
-            </a:r>
-          </a:p>
-          <a:p>
-            <a:pPr lvl="1"/>
-            <a:r>
-              <a:rPr lang="en-US" sz="1700"/>
-              <a:t>the histogram shows peaks and gaps most directly - the step plot turns a gap into a flat shelf, and the boxplot loses it altogether</a:t>
-            </a:r>
-          </a:p>
-        </p:txBody>
-      </p:sp>
-      <p:sp>
-        <p:nvSpPr>
-          <p:cNvPr id="4" name="Slide Number Placeholder 3">
-            <a:extLst>
-              <a:ext uri="{FF2B5EF4-FFF2-40B4-BE49-F238E27FC236}">
-                <a16:creationId xmlns:a16="http://schemas.microsoft.com/office/drawing/2014/main" id="{CE843DF3-42DB-0E12-0986-C4457667B0DE}"/>
-              </a:ext>
-            </a:extLst>
-          </p:cNvPr>
-          <p:cNvSpPr>
-            <a:spLocks noGrp="1"/>
-          </p:cNvSpPr>
-          <p:nvPr>
-            <p:ph type="sldNum" sz="quarter" idx="12"/>
-          </p:nvPr>
-        </p:nvSpPr>
-        <p:spPr/>
-        <p:txBody>
-          <a:bodyPr/>
-          <a:lstStyle/>
-          <a:p>
-            <a:fld id="{A80A81DD-F10A-4B1C-963A-0ABBB4865886}" type="slidenum">
-              <a:rPr lang="en-US" sz="1600" smtClean="0"/>
-              <a:t>10</a:t>
-            </a:fld>
-            <a:endParaRPr lang="en-US" sz="1600"/>
-          </a:p>
-        </p:txBody>
-      </p:sp>
-      <p:sp>
-        <p:nvSpPr>
-          <p:cNvPr id="5" name="Title rule">
-            <a:extLst>
-              <a:ext uri="{FF2B5EF4-FFF2-40B4-BE49-F238E27FC236}">
-                <a16:creationId xmlns:a16="http://schemas.microsoft.com/office/drawing/2014/main" id="{12E931F2-934C-1CAB-550B-A20AA18F3745}"/>
-              </a:ext>
-            </a:extLst>
-          </p:cNvPr>
-          <p:cNvSpPr/>
-          <p:nvPr/>
-        </p:nvSpPr>
-        <p:spPr>
-          <a:xfrm>
-            <a:off x="838200" y="1600200"/>
-            <a:ext cx="10515600" cy="38100"/>
-          </a:xfrm>
-          <a:prstGeom prst="rect">
-            <a:avLst/>
-          </a:prstGeom>
-          <a:solidFill>
-            <a:srgbClr val="4472C4"/>
-          </a:solidFill>
-          <a:ln w="12700" cap="flat" cmpd="sng" algn="ctr">
-            <a:noFill/>
-            <a:prstDash val="solid"/>
-            <a:miter lim="800000"/>
-          </a:ln>
-          <a:effectLst/>
-          <a:extLst>
-            <a:ext uri="{91240B29-F687-4F45-9708-019B960494DF}">
-              <a14:hiddenLine xmlns:a14="http://schemas.microsoft.com/office/drawing/2010/main" w="12700" cap="flat" cmpd="sng" algn="ctr">
-                <a:solidFill>
-                  <a:schemeClr val="accent1">
-                    <a:shade val="15000"/>
-                  </a:schemeClr>
-                </a:solidFill>
-                <a:prstDash val="solid"/>
-                <a:miter lim="800000"/>
-              </a14:hiddenLine>
-            </a:ext>
-          </a:extLst>
-        </p:spPr>
-        <p:style>
-          <a:lnRef idx="2">
-            <a:schemeClr val="accent1">
-              <a:shade val="15000"/>
-            </a:schemeClr>
-          </a:lnRef>
-          <a:fillRef idx="1">
-            <a:schemeClr val="accent1"/>
-          </a:fillRef>
-          <a:effectRef idx="0">
-            <a:schemeClr val="accent1"/>
-          </a:effectRef>
-          <a:fontRef idx="minor">
-            <a:schemeClr val="lt1"/>
-          </a:fontRef>
-        </p:style>
-        <p:txBody>
-          <a:bodyPr rtlCol="0" anchor="ctr"/>
-          <a:lstStyle/>
-          <a:p>
-            <a:pPr algn="ctr"/>
-            <a:endParaRPr lang="en-US"/>
-          </a:p>
-        </p:txBody>
-      </p:sp>
-    </p:spTree>
-    <p:extLst>
-      <p:ext uri="{BB962C8B-B14F-4D97-AF65-F5344CB8AC3E}">
-        <p14:creationId xmlns:p14="http://schemas.microsoft.com/office/powerpoint/2010/main" val="1407277174"/>
-      </p:ext>
-    </p:extLst>
-  </p:cSld>
-  <p:clrMapOvr>
-    <a:masterClrMapping/>
-  </p:clrMapOvr>
-</p:sld>
-</file>
-
-<file path=ppt/slides/slide14.xml><?xml version="1.0" encoding="utf-8"?>
-<p:sld xmlns:a="http://schemas.openxmlformats.org/drawingml/2006/main" xmlns:r="http://schemas.openxmlformats.org/officeDocument/2006/relationships" xmlns:p="http://schemas.openxmlformats.org/presentationml/2006/main">
-  <p:cSld>
-    <p:spTree>
-      <p:nvGrpSpPr>
-        <p:cNvPr id="1" name=""/>
-        <p:cNvGrpSpPr/>
-        <p:nvPr/>
-      </p:nvGrpSpPr>
-      <p:grpSpPr>
-        <a:xfrm>
-          <a:off x="0" y="0"/>
-          <a:ext cx="0" cy="0"/>
-          <a:chOff x="0" y="0"/>
-          <a:chExt cx="0" cy="0"/>
-        </a:xfrm>
-      </p:grpSpPr>
-      <p:sp>
-        <p:nvSpPr>
-          <p:cNvPr id="6" name="Body card">
-            <a:extLst>
-              <a:ext uri="{FF2B5EF4-FFF2-40B4-BE49-F238E27FC236}">
-                <a16:creationId xmlns:a16="http://schemas.microsoft.com/office/drawing/2014/main" id="{A9C13C19-74B4-0526-F6A1-5654F679E9F7}"/>
-              </a:ext>
-            </a:extLst>
-          </p:cNvPr>
-          <p:cNvSpPr/>
-          <p:nvPr/>
-        </p:nvSpPr>
-        <p:spPr>
-          <a:xfrm>
-            <a:off x="635000" y="1689100"/>
-            <a:ext cx="10922000" cy="2717800"/>
-          </a:xfrm>
-          <a:prstGeom prst="roundRect">
-            <a:avLst>
-              <a:gd name="adj" fmla="val 3000"/>
-            </a:avLst>
-          </a:prstGeom>
-          <a:solidFill>
-            <a:srgbClr val="F2F6FC"/>
-          </a:solidFill>
-          <a:ln w="19050">
-            <a:solidFill>
-              <a:srgbClr val="4472C4"/>
-            </a:solidFill>
-          </a:ln>
-        </p:spPr>
-        <p:style>
-          <a:lnRef idx="2">
-            <a:schemeClr val="accent1">
-              <a:shade val="15000"/>
-            </a:schemeClr>
-          </a:lnRef>
-          <a:fillRef idx="1">
-            <a:schemeClr val="accent1"/>
-          </a:fillRef>
-          <a:effectRef idx="0">
-            <a:schemeClr val="accent1"/>
-          </a:effectRef>
-          <a:fontRef idx="minor">
-            <a:schemeClr val="lt1"/>
-          </a:fontRef>
-        </p:style>
-        <p:txBody>
-          <a:bodyPr rtlCol="0" anchor="ctr"/>
-          <a:lstStyle/>
-          <a:p>
-            <a:pPr algn="ctr"/>
-            <a:endParaRPr lang="en-US"/>
-          </a:p>
-        </p:txBody>
-      </p:sp>
-      <p:sp>
-        <p:nvSpPr>
-          <p:cNvPr id="2" name="Title 1">
-            <a:extLst>
-              <a:ext uri="{FF2B5EF4-FFF2-40B4-BE49-F238E27FC236}">
-                <a16:creationId xmlns:a16="http://schemas.microsoft.com/office/drawing/2014/main" id="{B43EDA93-D433-A68C-C5CB-A4459A9F1B13}"/>
-              </a:ext>
-            </a:extLst>
-          </p:cNvPr>
-          <p:cNvSpPr>
-            <a:spLocks noGrp="1"/>
-          </p:cNvSpPr>
-          <p:nvPr>
-            <p:ph type="title"/>
-          </p:nvPr>
-        </p:nvSpPr>
-        <p:spPr/>
-        <p:txBody>
-          <a:bodyPr>
-            <a:noAutofit/>
-          </a:bodyPr>
-          <a:lstStyle/>
-          <a:p>
-            <a:r>
-              <a:rPr lang="en-US">
-                <a:solidFill>
-                  <a:srgbClr val="1F3864"/>
-                </a:solidFill>
-              </a:rPr>
-              <a:t>Descriptive statistics: the whole toolkit</a:t>
-            </a:r>
-          </a:p>
-        </p:txBody>
-      </p:sp>
-      <p:sp>
-        <p:nvSpPr>
-          <p:cNvPr id="3" name="Content Placeholder 2">
-            <a:extLst>
-              <a:ext uri="{FF2B5EF4-FFF2-40B4-BE49-F238E27FC236}">
-                <a16:creationId xmlns:a16="http://schemas.microsoft.com/office/drawing/2014/main" id="{A82EB072-EB9A-10EB-609A-BE80F7266276}"/>
-              </a:ext>
-            </a:extLst>
-          </p:cNvPr>
-          <p:cNvSpPr>
-            <a:spLocks noGrp="1"/>
-          </p:cNvSpPr>
-          <p:nvPr>
-            <p:ph idx="1"/>
-          </p:nvPr>
-        </p:nvSpPr>
-        <p:spPr>
-          <a:xfrm>
-            <a:off x="762000" y="1841500"/>
-            <a:ext cx="10668000" cy="4191000"/>
-          </a:xfrm>
-        </p:spPr>
-        <p:txBody>
-          <a:bodyPr>
-            <a:noAutofit/>
-          </a:bodyPr>
-          <a:lstStyle/>
-          <a:p>
-            <a:r>
-              <a:rPr lang="en-US" sz="1600"/>
-              <a:t>Every question we have asked about a single variable falls into four buckets</a:t>
-            </a:r>
-          </a:p>
-          <a:p>
-            <a:pPr lvl="1"/>
-            <a:r>
-              <a:rPr lang="en-US" sz="1600" b="1">
-                <a:solidFill>
-                  <a:srgbClr val="C00000"/>
-                </a:solidFill>
-              </a:rPr>
-              <a:t>SHAPE</a:t>
-            </a:r>
-            <a:r>
-              <a:rPr lang="en-US" sz="1600"/>
-              <a:t> - symmetric, skewed, how many peaks, gaps and outliers  (histogram, dot plot, stem and leaf, boxplot)</a:t>
-            </a:r>
-          </a:p>
-          <a:p>
-            <a:pPr lvl="1"/>
-            <a:r>
-              <a:rPr lang="en-US" sz="1600" b="1">
-                <a:solidFill>
-                  <a:srgbClr val="C00000"/>
-                </a:solidFill>
-              </a:rPr>
-              <a:t>CENTER</a:t>
-            </a:r>
-            <a:r>
-              <a:rPr lang="en-US" sz="1600"/>
-              <a:t> - mean, median, mode</a:t>
-            </a:r>
-          </a:p>
-          <a:p>
-            <a:pPr lvl="1"/>
-            <a:r>
-              <a:rPr lang="en-US" sz="1600" b="1">
-                <a:solidFill>
-                  <a:srgbClr val="C00000"/>
-                </a:solidFill>
-              </a:rPr>
-              <a:t>SPREAD</a:t>
-            </a:r>
-            <a:r>
-              <a:rPr lang="en-US" sz="1600"/>
-              <a:t> - range, IQR, variance, standard deviation</a:t>
-            </a:r>
-          </a:p>
-          <a:p>
-            <a:pPr lvl="1"/>
-            <a:r>
-              <a:rPr lang="en-US" sz="1600" b="1">
-                <a:solidFill>
-                  <a:srgbClr val="C00000"/>
-                </a:solidFill>
-              </a:rPr>
-              <a:t>POSITION</a:t>
-            </a:r>
-            <a:r>
-              <a:rPr lang="en-US" sz="1600"/>
-              <a:t> - percentiles and quartiles  (ordered data, or the cumulative distribution)</a:t>
-            </a:r>
-          </a:p>
-          <a:p>
-            <a:r>
-              <a:rPr lang="en-US" sz="1600"/>
-              <a:t>Resistant to outliers: the median, the mode, the IQR</a:t>
-            </a:r>
-          </a:p>
-          <a:p>
-            <a:r>
-              <a:rPr lang="en-US" sz="1600"/>
-              <a:t>Not resistant: the mean, the range, the variance and the standard deviation</a:t>
-            </a:r>
-          </a:p>
-          <a:p>
-            <a:r>
-              <a:rPr lang="en-US" sz="1600"/>
-              <a:t>Shape decides which pair you report - mean with s, or median with IQR</a:t>
-            </a:r>
-          </a:p>
-        </p:txBody>
-      </p:sp>
-      <p:sp>
-        <p:nvSpPr>
-          <p:cNvPr id="4" name="Slide Number Placeholder 3">
-            <a:extLst>
-              <a:ext uri="{FF2B5EF4-FFF2-40B4-BE49-F238E27FC236}">
-                <a16:creationId xmlns:a16="http://schemas.microsoft.com/office/drawing/2014/main" id="{19B4C654-64F1-DBAE-291C-773F9B79613D}"/>
-              </a:ext>
-            </a:extLst>
-          </p:cNvPr>
-          <p:cNvSpPr>
-            <a:spLocks noGrp="1"/>
-          </p:cNvSpPr>
-          <p:nvPr>
-            <p:ph type="sldNum" sz="quarter" idx="12"/>
-          </p:nvPr>
-        </p:nvSpPr>
-        <p:spPr/>
-        <p:txBody>
-          <a:bodyPr/>
-          <a:lstStyle/>
-          <a:p>
-            <a:fld id="{A80A81DD-F10A-4B1C-963A-0ABBB4865886}" type="slidenum">
-              <a:rPr lang="en-US" sz="1600" smtClean="0"/>
-              <a:t>11</a:t>
-            </a:fld>
-            <a:endParaRPr lang="en-US" sz="1600"/>
-          </a:p>
-        </p:txBody>
-      </p:sp>
-      <p:sp>
-        <p:nvSpPr>
-          <p:cNvPr id="5" name="Title rule">
-            <a:extLst>
-              <a:ext uri="{FF2B5EF4-FFF2-40B4-BE49-F238E27FC236}">
-                <a16:creationId xmlns:a16="http://schemas.microsoft.com/office/drawing/2014/main" id="{847554A2-B6FE-FB4C-022A-166460DAF70E}"/>
-              </a:ext>
-            </a:extLst>
-          </p:cNvPr>
-          <p:cNvSpPr/>
-          <p:nvPr/>
-        </p:nvSpPr>
-        <p:spPr>
-          <a:xfrm>
-            <a:off x="838200" y="1600200"/>
-            <a:ext cx="10515600" cy="38100"/>
-          </a:xfrm>
-          <a:prstGeom prst="rect">
-            <a:avLst/>
-          </a:prstGeom>
-          <a:solidFill>
-            <a:srgbClr val="4472C4"/>
-          </a:solidFill>
-          <a:ln w="12700" cap="flat" cmpd="sng" algn="ctr">
-            <a:noFill/>
-            <a:prstDash val="solid"/>
-            <a:miter lim="800000"/>
-          </a:ln>
-          <a:effectLst/>
-          <a:extLst>
-            <a:ext uri="{91240B29-F687-4F45-9708-019B960494DF}">
-              <a14:hiddenLine xmlns:a14="http://schemas.microsoft.com/office/drawing/2010/main" w="12700" cap="flat" cmpd="sng" algn="ctr">
-                <a:solidFill>
-                  <a:schemeClr val="accent1">
-                    <a:shade val="15000"/>
-                  </a:schemeClr>
-                </a:solidFill>
-                <a:prstDash val="solid"/>
-                <a:miter lim="800000"/>
-              </a14:hiddenLine>
-            </a:ext>
-          </a:extLst>
-        </p:spPr>
-        <p:style>
-          <a:lnRef idx="2">
-            <a:schemeClr val="accent1">
-              <a:shade val="15000"/>
-            </a:schemeClr>
-          </a:lnRef>
-          <a:fillRef idx="1">
-            <a:schemeClr val="accent1"/>
-          </a:fillRef>
-          <a:effectRef idx="0">
-            <a:schemeClr val="accent1"/>
-          </a:effectRef>
-          <a:fontRef idx="minor">
-            <a:schemeClr val="lt1"/>
-          </a:fontRef>
-        </p:style>
-        <p:txBody>
-          <a:bodyPr rtlCol="0" anchor="ctr"/>
-          <a:lstStyle/>
-          <a:p>
-            <a:pPr algn="ctr"/>
-            <a:endParaRPr lang="en-US"/>
-          </a:p>
-        </p:txBody>
-      </p:sp>
-    </p:spTree>
-    <p:extLst>
-      <p:ext uri="{BB962C8B-B14F-4D97-AF65-F5344CB8AC3E}">
-        <p14:creationId xmlns:p14="http://schemas.microsoft.com/office/powerpoint/2010/main" val="2758489216"/>
-      </p:ext>
-    </p:extLst>
-  </p:cSld>
-  <p:clrMapOvr>
-    <a:masterClrMapping/>
-  </p:clrMapOvr>
-</p:sld>
-</file>
-
-<file path=ppt/slides/slide15.xml><?xml version="1.0" encoding="utf-8"?>
-<p:sld xmlns:a="http://schemas.openxmlformats.org/drawingml/2006/main" xmlns:r="http://schemas.openxmlformats.org/officeDocument/2006/relationships" xmlns:p="http://schemas.openxmlformats.org/presentationml/2006/main">
-  <p:cSld>
-    <p:spTree>
-      <p:nvGrpSpPr>
-        <p:cNvPr id="1" name=""/>
-        <p:cNvGrpSpPr/>
-        <p:nvPr/>
-      </p:nvGrpSpPr>
-      <p:grpSpPr>
-        <a:xfrm>
-          <a:off x="0" y="0"/>
-          <a:ext cx="0" cy="0"/>
-          <a:chOff x="0" y="0"/>
-          <a:chExt cx="0" cy="0"/>
-        </a:xfrm>
-      </p:grpSpPr>
-      <p:sp>
-        <p:nvSpPr>
-          <p:cNvPr id="6" name="Body card">
-            <a:extLst>
-              <a:ext uri="{FF2B5EF4-FFF2-40B4-BE49-F238E27FC236}">
-                <a16:creationId xmlns:a16="http://schemas.microsoft.com/office/drawing/2014/main" id="{CD8D8ABA-4AE8-EB6F-6B42-92339DC54E52}"/>
-              </a:ext>
-            </a:extLst>
-          </p:cNvPr>
-          <p:cNvSpPr/>
-          <p:nvPr/>
-        </p:nvSpPr>
-        <p:spPr>
-          <a:xfrm>
-            <a:off x="635000" y="1689100"/>
-            <a:ext cx="10922000" cy="2895600"/>
-          </a:xfrm>
-          <a:prstGeom prst="roundRect">
-            <a:avLst>
-              <a:gd name="adj" fmla="val 3000"/>
-            </a:avLst>
-          </a:prstGeom>
-          <a:solidFill>
-            <a:srgbClr val="F2F6FC"/>
-          </a:solidFill>
-          <a:ln w="19050">
-            <a:solidFill>
-              <a:srgbClr val="4472C4"/>
-            </a:solidFill>
-          </a:ln>
-        </p:spPr>
-        <p:style>
-          <a:lnRef idx="2">
-            <a:schemeClr val="accent1">
-              <a:shade val="15000"/>
-            </a:schemeClr>
-          </a:lnRef>
-          <a:fillRef idx="1">
-            <a:schemeClr val="accent1"/>
-          </a:fillRef>
-          <a:effectRef idx="0">
-            <a:schemeClr val="accent1"/>
-          </a:effectRef>
-          <a:fontRef idx="minor">
-            <a:schemeClr val="lt1"/>
-          </a:fontRef>
-        </p:style>
-        <p:txBody>
-          <a:bodyPr rtlCol="0" anchor="ctr"/>
-          <a:lstStyle/>
-          <a:p>
-            <a:pPr algn="ctr"/>
-            <a:endParaRPr lang="en-US"/>
-          </a:p>
-        </p:txBody>
-      </p:sp>
-      <p:sp>
-        <p:nvSpPr>
-          <p:cNvPr id="2" name="Title 1">
-            <a:extLst>
-              <a:ext uri="{FF2B5EF4-FFF2-40B4-BE49-F238E27FC236}">
-                <a16:creationId xmlns:a16="http://schemas.microsoft.com/office/drawing/2014/main" id="{2A68CE20-5AFC-F034-2451-7658C82C3938}"/>
-              </a:ext>
-            </a:extLst>
-          </p:cNvPr>
-          <p:cNvSpPr>
-            <a:spLocks noGrp="1"/>
-          </p:cNvSpPr>
-          <p:nvPr>
-            <p:ph type="title"/>
-          </p:nvPr>
-        </p:nvSpPr>
-        <p:spPr/>
-        <p:txBody>
-          <a:bodyPr>
-            <a:noAutofit/>
-          </a:bodyPr>
-          <a:lstStyle/>
-          <a:p>
-            <a:r>
-              <a:rPr lang="en-US">
-                <a:solidFill>
-                  <a:srgbClr val="1F3864"/>
-                </a:solidFill>
-              </a:rPr>
-              <a:t>End of the material for Exam 1</a:t>
-            </a:r>
-          </a:p>
-        </p:txBody>
-      </p:sp>
-      <p:sp>
-        <p:nvSpPr>
-          <p:cNvPr id="3" name="Content Placeholder 2">
-            <a:extLst>
-              <a:ext uri="{FF2B5EF4-FFF2-40B4-BE49-F238E27FC236}">
-                <a16:creationId xmlns:a16="http://schemas.microsoft.com/office/drawing/2014/main" id="{10DBD34B-62F7-D8C7-7D2F-BAB277DD5DD2}"/>
-              </a:ext>
-            </a:extLst>
-          </p:cNvPr>
-          <p:cNvSpPr>
-            <a:spLocks noGrp="1"/>
-          </p:cNvSpPr>
-          <p:nvPr>
-            <p:ph idx="1"/>
-          </p:nvPr>
-        </p:nvSpPr>
-        <p:spPr>
-          <a:xfrm>
-            <a:off x="762000" y="1841500"/>
-            <a:ext cx="10668000" cy="4191000"/>
-          </a:xfrm>
-        </p:spPr>
-        <p:txBody>
-          <a:bodyPr>
-            <a:noAutofit/>
-          </a:bodyPr>
-          <a:lstStyle/>
-          <a:p>
-            <a:r>
-              <a:rPr lang="en-US" sz="1700"/>
-              <a:t>Everything on Exam 1 has now been covered. Monday starts new material that is NOT on it.</a:t>
-            </a:r>
-          </a:p>
-          <a:p>
-            <a:r>
-              <a:rPr lang="en-US" sz="1700"/>
-              <a:t>Wednesday September 16 - in-class review</a:t>
-            </a:r>
-          </a:p>
-          <a:p>
-            <a:r>
-              <a:rPr lang="en-US" sz="1700"/>
-              <a:t>Friday September 18 - Exam 1, in class</a:t>
-            </a:r>
-          </a:p>
-          <a:p>
-            <a:pPr lvl="1"/>
-            <a:r>
-              <a:rPr lang="en-US" sz="1700"/>
-              <a:t>delivered through Canvas, so bring a charged laptop</a:t>
-            </a:r>
-          </a:p>
-          <a:p>
-            <a:pPr lvl="1"/>
-            <a:r>
-              <a:rPr lang="en-US" sz="1700"/>
-              <a:t>a calculator is allowed, as long as it cannot communicate wirelessly</a:t>
-            </a:r>
-          </a:p>
-          <a:p>
-            <a:pPr lvl="1"/>
-            <a:r>
-              <a:rPr lang="en-US" sz="1700"/>
-              <a:t>notes are not permitted; the formula sheet is printed on the study guide</a:t>
-            </a:r>
-          </a:p>
-          <a:p>
-            <a:r>
-              <a:rPr lang="en-US" sz="1700"/>
-              <a:t>The study guide and the review problems are on the course website, under Exam Study Guides</a:t>
-            </a:r>
-          </a:p>
-          <a:p>
-            <a:r>
-              <a:rPr lang="en-US" sz="1700" b="1">
-                <a:solidFill>
-                  <a:srgbClr val="C00000"/>
-                </a:solidFill>
-              </a:rPr>
-              <a:t>Homework 1</a:t>
-            </a:r>
-            <a:r>
-              <a:rPr lang="en-US" sz="1700"/>
-              <a:t> is due Sunday at 11:59 PM</a:t>
-            </a:r>
-          </a:p>
-        </p:txBody>
-      </p:sp>
-      <p:sp>
-        <p:nvSpPr>
-          <p:cNvPr id="4" name="Slide Number Placeholder 3">
-            <a:extLst>
-              <a:ext uri="{FF2B5EF4-FFF2-40B4-BE49-F238E27FC236}">
-                <a16:creationId xmlns:a16="http://schemas.microsoft.com/office/drawing/2014/main" id="{F3CF01E7-F963-89EA-0572-B4C92D2C7493}"/>
-              </a:ext>
-            </a:extLst>
-          </p:cNvPr>
-          <p:cNvSpPr>
-            <a:spLocks noGrp="1"/>
-          </p:cNvSpPr>
-          <p:nvPr>
-            <p:ph type="sldNum" sz="quarter" idx="12"/>
-          </p:nvPr>
-        </p:nvSpPr>
-        <p:spPr/>
-        <p:txBody>
-          <a:bodyPr/>
-          <a:lstStyle/>
-          <a:p>
-            <a:fld id="{A80A81DD-F10A-4B1C-963A-0ABBB4865886}" type="slidenum">
-              <a:rPr lang="en-US" sz="1600" smtClean="0"/>
-              <a:t>12</a:t>
-            </a:fld>
-            <a:endParaRPr lang="en-US" sz="1600"/>
-          </a:p>
-        </p:txBody>
-      </p:sp>
-      <p:sp>
-        <p:nvSpPr>
-          <p:cNvPr id="5" name="Title rule">
-            <a:extLst>
-              <a:ext uri="{FF2B5EF4-FFF2-40B4-BE49-F238E27FC236}">
-                <a16:creationId xmlns:a16="http://schemas.microsoft.com/office/drawing/2014/main" id="{B9B35D6F-8821-8D85-B2DE-A3D8ECC9EEF8}"/>
-              </a:ext>
-            </a:extLst>
-          </p:cNvPr>
-          <p:cNvSpPr/>
-          <p:nvPr/>
-        </p:nvSpPr>
-        <p:spPr>
-          <a:xfrm>
-            <a:off x="838200" y="1600200"/>
-            <a:ext cx="10515600" cy="38100"/>
-          </a:xfrm>
-          <a:prstGeom prst="rect">
-            <a:avLst/>
-          </a:prstGeom>
-          <a:solidFill>
-            <a:srgbClr val="4472C4"/>
-          </a:solidFill>
-          <a:ln w="12700" cap="flat" cmpd="sng" algn="ctr">
-            <a:noFill/>
-            <a:prstDash val="solid"/>
-            <a:miter lim="800000"/>
-          </a:ln>
-          <a:effectLst/>
-          <a:extLst>
-            <a:ext uri="{91240B29-F687-4F45-9708-019B960494DF}">
-              <a14:hiddenLine xmlns:a14="http://schemas.microsoft.com/office/drawing/2010/main" w="12700" cap="flat" cmpd="sng" algn="ctr">
-                <a:solidFill>
-                  <a:schemeClr val="accent1">
-                    <a:shade val="15000"/>
-                  </a:schemeClr>
-                </a:solidFill>
-                <a:prstDash val="solid"/>
-                <a:miter lim="800000"/>
-              </a14:hiddenLine>
-            </a:ext>
-          </a:extLst>
-        </p:spPr>
-        <p:style>
-          <a:lnRef idx="2">
-            <a:schemeClr val="accent1">
-              <a:shade val="15000"/>
-            </a:schemeClr>
-          </a:lnRef>
-          <a:fillRef idx="1">
-            <a:schemeClr val="accent1"/>
-          </a:fillRef>
-          <a:effectRef idx="0">
-            <a:schemeClr val="accent1"/>
-          </a:effectRef>
-          <a:fontRef idx="minor">
-            <a:schemeClr val="lt1"/>
-          </a:fontRef>
-        </p:style>
-        <p:txBody>
-          <a:bodyPr rtlCol="0" anchor="ctr"/>
-          <a:lstStyle/>
-          <a:p>
-            <a:pPr algn="ctr"/>
-            <a:endParaRPr lang="en-US"/>
-          </a:p>
-        </p:txBody>
-      </p:sp>
-    </p:spTree>
-    <p:extLst>
-      <p:ext uri="{BB962C8B-B14F-4D97-AF65-F5344CB8AC3E}">
-        <p14:creationId xmlns:p14="http://schemas.microsoft.com/office/powerpoint/2010/main" val="411597834"/>
       </p:ext>
     </p:extLst>
   </p:cSld>
@@ -6942,7 +6011,7 @@
           <a:p>
             <a:fld id="{A80A81DD-F10A-4B1C-963A-0ABBB4865886}" type="slidenum">
               <a:rPr lang="en-US" sz="1600" smtClean="0"/>
-              <a:t>3</a:t>
+              <a:t>4</a:t>
             </a:fld>
             <a:endParaRPr lang="en-US" sz="1600"/>
           </a:p>
@@ -7231,7 +6300,7 @@
           <a:p>
             <a:fld id="{A80A81DD-F10A-4B1C-963A-0ABBB4865886}" type="slidenum">
               <a:rPr lang="en-US" sz="1600" smtClean="0"/>
-              <a:t>4</a:t>
+              <a:t>5</a:t>
             </a:fld>
             <a:endParaRPr lang="en-US" sz="1600"/>
           </a:p>
@@ -7481,7 +6550,7 @@
           <a:p>
             <a:fld id="{A80A81DD-F10A-4B1C-963A-0ABBB4865886}" type="slidenum">
               <a:rPr lang="en-US" sz="1600" smtClean="0"/>
-              <a:t>5</a:t>
+              <a:t>6</a:t>
             </a:fld>
             <a:endParaRPr lang="en-US" sz="1600"/>
           </a:p>
@@ -7758,7 +6827,7 @@
           <a:p>
             <a:fld id="{A80A81DD-F10A-4B1C-963A-0ABBB4865886}" type="slidenum">
               <a:rPr lang="en-US" sz="1600" smtClean="0"/>
-              <a:t>6</a:t>
+              <a:t>7</a:t>
             </a:fld>
             <a:endParaRPr lang="en-US" sz="1600"/>
           </a:p>
@@ -8041,7 +7110,7 @@
           <a:p>
             <a:fld id="{A80A81DD-F10A-4B1C-963A-0ABBB4865886}" type="slidenum">
               <a:rPr lang="en-US" sz="1600" smtClean="0"/>
-              <a:t>7</a:t>
+              <a:t>8</a:t>
             </a:fld>
             <a:endParaRPr lang="en-US" sz="1600"/>
           </a:p>
@@ -8306,7 +7375,7 @@
           <a:p>
             <a:fld id="{A80A81DD-F10A-4B1C-963A-0ABBB4865886}" type="slidenum">
               <a:rPr lang="en-US" sz="1600" smtClean="0"/>
-              <a:t>8</a:t>
+              <a:t>9</a:t>
             </a:fld>
             <a:endParaRPr lang="en-US" sz="1600"/>
           </a:p>

</xml_diff>